<commit_message>
Correções do parecer: viés do linkage, sensibilidade no mesmo teste, calibração e utilidade clínica
- Sensibilidade ao linkage refeita: rótulos alternativos só no treino, avaliação no
  mesmo teste de 2023 com ΔAUROC por bootstrap pareado (estrito e pior caso)
- Comparação de óbitos pareados × não pareados pela DO e taxa de pareamento por subgrupo
- Intercepto/inclinação de calibração, curva de decisão, VIF, ausência informativa, gêmeos
- Manifesto dos dados (SHA-256) e aspectos éticos
- Relatório: H3 como na proposta, uso delimitado do modelo pré-parto, linguagem do
  linkage suavizada, premissa dos falsos pares explícita, +6 referências, link do código
- Slides: novo slide de calibração/utilidade, notas longas; roteiro de arguição

Co-Authored-By: Claude Opus 5.5 (1M context) <noreply@anthropic.com>
</commit_message>
<xml_diff>
--- a/slides/apresentacao.pptx
+++ b/slides/apresentacao.pptx
@@ -18,6 +18,7 @@
     <p:sldId id="266" r:id="rId18"/>
     <p:sldId id="267" r:id="rId19"/>
     <p:sldId id="268" r:id="rId20"/>
+    <p:sldId id="269" r:id="rId21"/>
   </p:sldIdLst>
   <p:sldSz cx="12191695" cy="6858000" type="screen4x3"/>
   <p:notesSz cx="6858000" cy="9144000"/>
@@ -514,7 +515,7 @@
           <a:lstStyle/>
           <a:p>
             <a:r>
-              <a:t>Apresento a reprodução, no estado do Rio, de um modelo brasileiro de predição de mortalidade neonatal, usando apenas dados públicos do DATASUS.</a:t>
+              <a:t>Boa tarde. Vou apresentar meu projeto de aplicação: prever o óbito neonatal no estado do Rio de Janeiro usando só dados abertos do SUS. O trabalho parte de um artigo brasileiro, que fez isso em São Paulo com dados identificados. A pergunta central é se dá para chegar ao mesmo resultado sem acesso privilegiado aos dados. Para isso, construí um linkage entre nascimentos e óbitos sem nenhum identificador. Vou mostrar como o linkage foi feito, o quanto ele erra e se esses erros afetam as conclusões. Depois apresento os modelos, a calibração, a utilidade clínica e as limitações.</a:t>
             </a:r>
           </a:p>
         </p:txBody>
@@ -584,7 +585,7 @@
           <a:lstStyle/>
           <a:p>
             <a:r>
-              <a:t>O modelo pré-parto perde discriminação, mas ainda separa bem, principalmente pela idade gestacional. Ele é o que pode ser usado antes do nascimento, para regulação.</a:t>
+              <a:t>O modelo pré-parto perde 0,066 de AUROC e bem mais de AUPRC, mas ainda chega a 0,890. H2 se confirma em parte: perdeu, mas continua útil. Pelo SHAP, quase tudo vem da idade gestacional. Por isso, o uso precisa ser bem delimitado: na admissão, com o parto iminente, para decidir transferência in utero para uma maternidade com UTI neonatal e preparar a equipe. Ele não serve para triagem precoce da gestação, porque nem a idade gestacional do parto nem as consultas acumuladas são conhecidas semanas antes. Essa é uma pergunta provável da banca.</a:t>
             </a:r>
           </a:p>
         </p:txBody>
@@ -654,7 +655,7 @@
           <a:lstStyle/>
           <a:p>
             <a:r>
-              <a:t>A calibração global é boa. As diferenças por subgrupo são pequenas; a maior parte dos IC se sobrepõe, então H3 tem apoio apenas fraco.</a:t>
+              <a:t>A pergunta mais provável é se os erros do linkage explicam os resultados. Para testar, reajustei o modelo com rótulos alternativos no treino, avaliando sempre no mesmo teste de 2023. No cenário estrito, removi os pares duvidosos. No pior caso, marquei-os como sobreviventes. A AUROC mudou -0,0001 e -0,0005, com intervalos que incluem zero. A discriminação é robusta. Mas o O/E sobe para até 1,23: a calibração absoluta depende da completude do linkage. As limitações principais são os rótulos imperfeitos, a falta de validação externa e o uso de variáveis do pós-parto no modelo A.</a:t>
             </a:r>
           </a:p>
         </p:txBody>
@@ -724,7 +725,7 @@
           <a:lstStyle/>
           <a:p>
             <a:r>
-              <a:t>A sensibilidade mostra que o resultado não depende das passadas tolerantes. As limitações principais são o linkage incompleto e a ausência de validação em outro estado.</a:t>
+              <a:t>Para concluir. Primeiro, dá para reproduzir o resultado do artigo com dados totalmente abertos, e a discriminação é robusta aos erros do linkage. Segundo, a calibração absoluta não é: depende da completude do linkage e do drift temporal, então um uso real exigiria recalibração periódica. Terceiro, o modelo na admissão para o parto tem desempenho útil para decisões de transferência. Como próximos passos: validar em outros estados, acrescentar uma etapa probabilística ao linkage e avaliar o impacto com gestores. O código e os dados de reprodução estão no repositório. Obrigado.</a:t>
             </a:r>
           </a:p>
         </p:txBody>
@@ -794,7 +795,77 @@
           <a:lstStyle/>
           <a:p>
             <a:r>
-              <a:t>Em resumo: é possível reproduzir o modelo do artigo com dados abertos, e um modelo pré-parto já tem desempenho útil. Obrigado.</a:t>
+              <a:t>Calibração e utilidade clínica. A inclinação de calibração é 0,98 no A e 0,99 no B, praticamente 1, então as previsões não são extremas demais. O intercepto do B é 0,063, que é exatamente o logaritmo de 8,20 sobre 7,70: a mortalidade subiu em 2023. É drift de prevalência, não defeito do modelo. Em uso real, o intercepto precisaria ser recalibrado periodicamente. A curva de decisão mostra benefício líquido acima de tratar todos e de tratar nenhum em todos os limiares de 1% a 20%. Esta é a métrica que diz se o modelo ajuda a decidir.</a:t>
+            </a:r>
+          </a:p>
+        </p:txBody>
+      </p:sp>
+      <p:sp>
+        <p:nvSpPr>
+          <p:cNvPr id="4" name="Slide Number Placeholder 3"/>
+          <p:cNvSpPr>
+            <a:spLocks noGrp="1"/>
+          </p:cNvSpPr>
+          <p:nvPr>
+            <p:ph type="sldNum" idx="5" sz="quarter"/>
+          </p:nvPr>
+        </p:nvSpPr>
+        <p:spPr/>
+      </p:sp>
+    </p:spTree>
+  </p:cSld>
+  <p:clrMapOvr>
+    <a:masterClrMapping/>
+  </p:clrMapOvr>
+</p:notes>
+</file>
+
+<file path=ppt/notesSlides/notesSlide14.xml><?xml version="1.0" encoding="utf-8"?>
+<p:notes xmlns:a="http://schemas.openxmlformats.org/drawingml/2006/main" xmlns:p="http://schemas.openxmlformats.org/presentationml/2006/main" xmlns:r="http://schemas.openxmlformats.org/officeDocument/2006/relationships">
+  <p:cSld>
+    <p:spTree>
+      <p:nvGrpSpPr>
+        <p:cNvPr id="1" name=""/>
+        <p:cNvGrpSpPr/>
+        <p:nvPr/>
+      </p:nvGrpSpPr>
+      <p:grpSpPr>
+        <a:xfrm>
+          <a:off x="0" y="0"/>
+          <a:ext cx="0" cy="0"/>
+          <a:chOff x="0" y="0"/>
+          <a:chExt cx="0" cy="0"/>
+        </a:xfrm>
+      </p:grpSpPr>
+      <p:sp>
+        <p:nvSpPr>
+          <p:cNvPr id="2" name="Slide Image Placeholder 1"/>
+          <p:cNvSpPr>
+            <a:spLocks noGrp="1"/>
+          </p:cNvSpPr>
+          <p:nvPr>
+            <p:ph type="sldImg" idx="2"/>
+          </p:nvPr>
+        </p:nvSpPr>
+        <p:spPr/>
+      </p:sp>
+      <p:sp>
+        <p:nvSpPr>
+          <p:cNvPr id="3" name="Notes Placeholder 2"/>
+          <p:cNvSpPr>
+            <a:spLocks noGrp="1"/>
+          </p:cNvSpPr>
+          <p:nvPr>
+            <p:ph type="body" idx="3" sz="quarter"/>
+          </p:nvPr>
+        </p:nvSpPr>
+        <p:spPr/>
+        <p:txBody>
+          <a:bodyPr/>
+          <a:lstStyle/>
+          <a:p>
+            <a:r>
+              <a:t>Subgrupos e H3. A hipótese era calibração pior na baixa escolaridade. O O/E nesse grupo foi 1,06, com intervalo que inclui 1 e se sobrepõe ao do ensino superior. Então H3 não se confirmou, e prefiro dizer isso claramente a trocar a hipótese depois de ver os dados. O modelo completo é homogêneo. O pré-parto subestima o risco para mães brancas e para o interior. No interior há uma explicação alternativa: o pareamento é menor lá. Para raça/cor, o pareamento é quase igual entre os grupos, então o linkage não explica.</a:t>
             </a:r>
           </a:p>
         </p:txBody>
@@ -864,7 +935,7 @@
           <a:lstStyle/>
           <a:p>
             <a:r>
-              <a:t>A mortalidade neonatal é a maior parcela da mortalidade infantil. A DN existe para todo nascimento, então um modelo baseado nela poderia ser aplicado em qualquer município.</a:t>
+              <a:t>Óbito neonatal é o que ocorre de 0 a 27 dias de vida. É a maior parte da mortalidade infantil. No RJ, entre 2017 e 2023, foram 8,6 óbitos por mil nascidos vivos, 12.039 ao todo. Boa parte é evitável, e o risco se concentra em poucos nascimentos. A Declaração de Nascido Vivo é preenchida para todo nascimento, em qualquer município. Um escore calculado a partir dela pode ajudar a priorizar UTI neonatal, transporte e visita domiciliar. A pergunta é se isso é possível com os dados que qualquer pesquisador pode baixar.</a:t>
             </a:r>
           </a:p>
         </p:txBody>
@@ -934,7 +1005,7 @@
           <a:lstStyle/>
           <a:p>
             <a:r>
-              <a:t>O artigo de referência é brasileiro e mostra desempenho muito alto. Mas depende de dados identificados, de uma única cidade, e não avalia calibração nem subgrupos.</a:t>
+              <a:t>O artigo de referência é de Batista e colegas, 2021, na BMC Pediatrics. Eles parearam nascimentos e óbitos de São Paulo usando nome e endereço, cedidos pela prefeitura. Com as 23 variáveis da DN, treinaram cinco algoritmos com validação temporal: treino até 2016 e teste em 2017. O XGBoost teve AUROC de 0,971, e os 5% de maior risco concentraram mais de 90% dos óbitos. As variáveis mais importantes foram Apgar, peso, anomalia e idade gestacional. É um resultado forte, mas numa única cidade e com dados que não estão disponíveis para terceiros.</a:t>
             </a:r>
           </a:p>
         </p:txBody>
@@ -1004,7 +1075,7 @@
           <a:lstStyle/>
           <a:p>
             <a:r>
-              <a:t>Três perguntas: reproduzir com dados abertos, medir o valor das variáveis do parto e verificar calibração e equidade, que a revisão sistemática de Mangold et al. aponta como lacunas da área.</a:t>
+              <a:t>Daí vêm três hipóteses, as mesmas da minha proposta. H1: com dados abertos, o modelo completo atinge AUROC de pelo menos 0,95. H2: um modelo só com o que se sabe na admissão para o parto perde desempenho, mas continua útil. H3: a calibração piora nos filhos de mães com menor escolaridade. As lacunas de calibração e de validação externa também aparecem na revisão sistemática de Mangold: só 45% dos estudos reportam calibração. Vou mostrar o resultado de cada hipótese, inclusive a que não se confirmou.</a:t>
             </a:r>
           </a:p>
         </p:txBody>
@@ -1074,7 +1145,7 @@
           <a:lstStyle/>
           <a:p>
             <a:r>
-              <a:t>Espelhamos o desenho do artigo: treinar no passado e testar no ano seguinte. O ano de 2022 serve só para escolhas de modelagem.</a:t>
+              <a:t>Os dados são o SINASC e o SIM do DATASUS, por residência no RJ, baixados do FTP público, sem cadastro. São 1.397.216 nascidos vivos. O SIM vai até 2024 para captar quem nasceu em dezembro de 2023. O desenho é temporal, como no artigo: ajuste em 2017 a 2021, validação em 2022 e teste em 2023, usado uma única vez. Um detalhe importante: a TMN do teste, 8,20, é maior que a do treino, 7,70. Isso vai aparecer na calibração. Registrei o hash SHA-256 de cada arquivo, porque o DATASUS revisa os dados.</a:t>
             </a:r>
           </a:p>
         </p:txBody>
@@ -1144,7 +1215,7 @@
           <a:lstStyle/>
           <a:p>
             <a:r>
-              <a:t>Esta é a principal contribuição metodológica: um linkage reproduzível com dados abertos, com taxa de pareamento comparável à obtida com nomes e endereços.</a:t>
+              <a:t>Esta é a parte central. Os arquivos públicos não têm o número da DN nem nomes. Mas a Declaração de Óbito de menores de um ano repete dados do nascimento. Então pareio por chaves compostas, em cascata, aceitando só pares únicos. Pareei 90,1% dos óbitos. Parte desses pares é falsa: estimei isso comparando campos que não entram nas chaves, e o resultado é cerca de 85% dos óbitos com par verdadeiro. A estimativa supõe que a primeira passada, com oito campos, não tem falsos pares. O pareamento é 94,3% na capital e 88,0% no interior. Os não pareados são os óbitos sem peso, semanas ou idade da mãe na DO: 27% deles não têm peso.</a:t>
             </a:r>
           </a:p>
         </p:txBody>
@@ -1214,7 +1285,7 @@
           <a:lstStyle/>
           <a:p>
             <a:r>
-              <a:t>O conjunto B responde à pergunta clínica de antes do parto. Todas as escolhas foram feitas em 2022.</a:t>
+              <a:t>Comparo dois conjuntos de variáveis. O A é o completo, como no artigo, com Apgar, peso e anomalia. O B tem só o que se sabe na admissão para o parto. Atenção: a idade gestacional do B é a do parto, e consultas e Kotelchuck dependem dela. Então o B responde a qual é o risco se o parto acontece agora, e não semanas antes. Uso três modelos: regressão logística como linha de base, XGBoost e LightGBM. Os hiperparâmetros vêm de busca bayesiana, maximizando a AUPRC, que é a métrica certa com 0,8% de positivos. Não usei SMOTE, para preservar a calibração.</a:t>
             </a:r>
           </a:p>
         </p:txBody>
@@ -1284,7 +1355,7 @@
           <a:lstStyle/>
           <a:p>
             <a:r>
-              <a:t>H1 se confirma: AUROC acima de 0,95 com dados abertos, um pouco abaixo do artigo. A diferença entre boosting e logística é pequena.</a:t>
+              <a:t>No teste de 2023, o XGBoost completo teve AUROC de 0,956 e AUPRC de 0,576. O artigo teve 0,971 e 0,586. H1 se confirma. A logística fica muito perto: o ganho do XGBoost em AUROC é de 0,003, com limite inferior praticamente zero, e o ganho mais claro está na AUPRC. Na prática, as variáveis da DN carregam quase toda a informação, e o algoritmo importa pouco. A precisão no limiar é maior e a sensibilidade menor que no artigo, mas isso decorre da escolha do limiar.</a:t>
             </a:r>
           </a:p>
         </p:txBody>
@@ -1354,7 +1425,7 @@
           <a:lstStyle/>
           <a:p>
             <a:r>
-              <a:t>Linhas cheias são o conjunto completo; tracejadas, o pré-parto. Os três modelos quase se sobrepõem.</a:t>
+              <a:t>Nas curvas, as linhas cheias são o modelo completo e as tracejadas, o pré-parto. Os três algoritmos quase se sobrepõem. À direita está a métrica operacional: priorizando 5% dos nascimentos, o modelo completo captura 87% dos óbitos e o pré-parto, 72%. Ramos e colegas, em 2025, com dados nacionais, encontraram mais de 85%, o que é coerente. A diferença para os 90% do artigo é compatível com os óbitos sem par verdadeiro, que são menos extremos e mais difíceis, e com a heterogeneidade do estado.</a:t>
             </a:r>
           </a:p>
         </p:txBody>
@@ -4724,7 +4795,7 @@
                 </a:solidFill>
                 <a:latin typeface="Calibri"/>
               </a:rPr>
-              <a:t>AUROC do modelo pré-parto (acima do esperado em H2)</a:t>
+              <a:t>AUROC do modelo na admissão para o parto</a:t>
             </a:r>
           </a:p>
         </p:txBody>
@@ -4886,7 +4957,7 @@
         <p:spPr>
           <a:xfrm>
             <a:off x="4114800" y="5120640"/>
-            <a:ext cx="7589520" cy="1188720"/>
+            <a:ext cx="7589520" cy="1280160"/>
           </a:xfrm>
           <a:prstGeom prst="rect">
             <a:avLst/>
@@ -4905,13 +4976,38 @@
               </a:spcAft>
             </a:pPr>
             <a:r>
-              <a:rPr sz="1500" b="0" i="0">
+              <a:rPr sz="1400" b="0" i="0">
                 <a:solidFill>
                   <a:srgbClr val="1F2A2E"/>
                 </a:solidFill>
                 <a:latin typeface="Calibri"/>
               </a:rPr>
-              <a:t>Sem as variáveis do parto, a idade gestacional domina; consultas de pré-natal, escolaridade e raça/cor da mãe ganham peso.</a:t>
+              <a:t>A idade gestacional domina, e consultas e Kotelchuck também dependem dela.</a:t>
+            </a:r>
+          </a:p>
+          <a:p>
+            <a:pPr algn="l">
+              <a:spcAft>
+                <a:spcPts val="600"/>
+              </a:spcAft>
+            </a:pPr>
+            <a:r>
+              <a:rPr sz="1400" b="1" i="0">
+                <a:solidFill>
+                  <a:srgbClr val="0B4F5C"/>
+                </a:solidFill>
+                <a:latin typeface="Calibri"/>
+              </a:rPr>
+              <a:t>Uso: </a:t>
+            </a:r>
+            <a:r>
+              <a:rPr sz="1400" b="0" i="0">
+                <a:solidFill>
+                  <a:srgbClr val="1F2A2E"/>
+                </a:solidFill>
+                <a:latin typeface="Calibri"/>
+              </a:rPr>
+              <a:t>risco na admissão, dado que o parto é agora (transferência in utero). Não serve para triagem precoce.</a:t>
             </a:r>
           </a:p>
         </p:txBody>
@@ -4976,7 +5072,7 @@
                 </a:solidFill>
                 <a:latin typeface="Cambria"/>
               </a:rPr>
-              <a:t>Calibração e subgrupos</a:t>
+              <a:t>Calibração e utilidade clínica</a:t>
             </a:r>
           </a:p>
         </p:txBody>
@@ -5015,14 +5111,14 @@
                 </a:solidFill>
                 <a:latin typeface="Calibri"/>
               </a:rPr>
-              <a:t>XGBoost recalibrado no teste de 2023, IC 95% por bootstrap</a:t>
+              <a:t>XGBoost recalibrado, teste de 2023</a:t>
             </a:r>
           </a:p>
         </p:txBody>
       </p:sp>
       <p:pic>
         <p:nvPicPr>
-          <p:cNvPr id="4" name="Picture 3" descr="subgrupos.png"/>
+          <p:cNvPr id="4" name="Picture 3" descr="curva_decisao.png"/>
           <p:cNvPicPr>
             <a:picLocks noChangeAspect="1"/>
           </p:cNvPicPr>
@@ -5036,8 +5132,8 @@
         </p:blipFill>
         <p:spPr>
           <a:xfrm>
-            <a:off x="548640" y="1463040"/>
-            <a:ext cx="7498079" cy="3565652"/>
+            <a:off x="548640" y="1554480"/>
+            <a:ext cx="7132320" cy="3231762"/>
           </a:xfrm>
           <a:prstGeom prst="rect">
             <a:avLst/>
@@ -5052,8 +5148,8 @@
         </p:nvSpPr>
         <p:spPr>
           <a:xfrm>
-            <a:off x="8229600" y="1645920"/>
-            <a:ext cx="3474720" cy="4754880"/>
+            <a:off x="7955279" y="1645920"/>
+            <a:ext cx="3749039" cy="4846320"/>
           </a:xfrm>
           <a:prstGeom prst="rect">
             <a:avLst/>
@@ -5079,7 +5175,7 @@
                 </a:solidFill>
                 <a:latin typeface="Calibri"/>
               </a:rPr>
-              <a:t>O/E global: 1,02 (A) e 1,05 (B).</a:t>
+              <a:t>Inclinação de calibração: 0,98 (A) e 0,99 (B), ideal 1.</a:t>
             </a:r>
           </a:p>
           <a:p>
@@ -5096,7 +5192,7 @@
                 </a:solidFill>
                 <a:latin typeface="Calibri"/>
               </a:rPr>
-              <a:t>No modelo A, a AUROC varia de 0,950 a 0,962 entre subgrupos, com IC sobrepostos.</a:t>
+              <a:t>Intercepto de B: 0,063 ≈ ln(8,20/7,70). É o aumento da TMN em 2023 (drift).</a:t>
             </a:r>
           </a:p>
           <a:p>
@@ -5113,7 +5209,7 @@
                 </a:solidFill>
                 <a:latin typeface="Calibri"/>
               </a:rPr>
-              <a:t>No pré-parto, a AUROC é menor na baixa escolaridade (0,868) e o risco de filhos de mães brancas é subestimado (O/E 1,15).</a:t>
+              <a:t>Benefício líquido acima de tratar todos/nenhum de 1% a 20%. Com pt = 5%: 5,6 por mil, sinalizando 1,9% dos nascimentos.</a:t>
             </a:r>
           </a:p>
         </p:txBody>
@@ -5178,7 +5274,218 @@
                 </a:solidFill>
                 <a:latin typeface="Cambria"/>
               </a:rPr>
-              <a:t>Sensibilidade e limitações</a:t>
+              <a:t>Subgrupos e H3</a:t>
+            </a:r>
+          </a:p>
+        </p:txBody>
+      </p:sp>
+      <p:sp>
+        <p:nvSpPr>
+          <p:cNvPr id="3" name="TextBox 2"/>
+          <p:cNvSpPr txBox="1"/>
+          <p:nvPr/>
+        </p:nvSpPr>
+        <p:spPr>
+          <a:xfrm>
+            <a:off x="548640" y="1097280"/>
+            <a:ext cx="11094415" cy="411480"/>
+          </a:xfrm>
+          <a:prstGeom prst="rect">
+            <a:avLst/>
+          </a:prstGeom>
+          <a:noFill/>
+        </p:spPr>
+        <p:txBody>
+          <a:bodyPr wrap="square" anchor="t" lIns="0" rIns="0" tIns="0" bIns="0">
+            <a:spAutoFit/>
+          </a:bodyPr>
+          <a:lstStyle/>
+          <a:p>
+            <a:pPr algn="l">
+              <a:spcAft>
+                <a:spcPts val="600"/>
+              </a:spcAft>
+            </a:pPr>
+            <a:r>
+              <a:rPr sz="1600" b="0" i="1">
+                <a:solidFill>
+                  <a:srgbClr val="5F6B70"/>
+                </a:solidFill>
+                <a:latin typeface="Calibri"/>
+              </a:rPr>
+              <a:t>IC 95% por bootstrap dentro de cada subgrupo</a:t>
+            </a:r>
+          </a:p>
+        </p:txBody>
+      </p:sp>
+      <p:pic>
+        <p:nvPicPr>
+          <p:cNvPr id="4" name="Picture 3" descr="subgrupos.png"/>
+          <p:cNvPicPr>
+            <a:picLocks noChangeAspect="1"/>
+          </p:cNvPicPr>
+          <p:nvPr/>
+        </p:nvPicPr>
+        <p:blipFill>
+          <a:blip r:embed="rId2"/>
+          <a:stretch>
+            <a:fillRect/>
+          </a:stretch>
+        </p:blipFill>
+        <p:spPr>
+          <a:xfrm>
+            <a:off x="548640" y="1463040"/>
+            <a:ext cx="7498079" cy="3565652"/>
+          </a:xfrm>
+          <a:prstGeom prst="rect">
+            <a:avLst/>
+          </a:prstGeom>
+        </p:spPr>
+      </p:pic>
+      <p:sp>
+        <p:nvSpPr>
+          <p:cNvPr id="5" name="TextBox 4"/>
+          <p:cNvSpPr txBox="1"/>
+          <p:nvPr/>
+        </p:nvSpPr>
+        <p:spPr>
+          <a:xfrm>
+            <a:off x="8229600" y="1645920"/>
+            <a:ext cx="3474720" cy="4754880"/>
+          </a:xfrm>
+          <a:prstGeom prst="rect">
+            <a:avLst/>
+          </a:prstGeom>
+          <a:noFill/>
+        </p:spPr>
+        <p:txBody>
+          <a:bodyPr wrap="square" anchor="t" lIns="0" rIns="0" tIns="0" bIns="0">
+            <a:spAutoFit/>
+          </a:bodyPr>
+          <a:lstStyle/>
+          <a:p>
+            <a:pPr algn="l" marL="256032" indent="-256032">
+              <a:spcAft>
+                <a:spcPts val="1000"/>
+              </a:spcAft>
+              <a:buChar char="•"/>
+            </a:pPr>
+            <a:r>
+              <a:rPr sz="1500" b="1" i="0">
+                <a:solidFill>
+                  <a:srgbClr val="0B4F5C"/>
+                </a:solidFill>
+                <a:latin typeface="Calibri"/>
+              </a:rPr>
+              <a:t>H3 não confirmada: </a:t>
+            </a:r>
+            <a:r>
+              <a:rPr sz="1500" b="0" i="0">
+                <a:solidFill>
+                  <a:srgbClr val="1F2A2E"/>
+                </a:solidFill>
+                <a:latin typeface="Calibri"/>
+              </a:rPr>
+              <a:t>O/E na baixa escolaridade 1,06 (IC 0,97–1,16), que inclui 1.</a:t>
+            </a:r>
+          </a:p>
+          <a:p>
+            <a:pPr algn="l" marL="256032" indent="-256032">
+              <a:spcAft>
+                <a:spcPts val="1000"/>
+              </a:spcAft>
+              <a:buChar char="•"/>
+            </a:pPr>
+            <a:r>
+              <a:rPr sz="1500" b="0" i="0">
+                <a:solidFill>
+                  <a:srgbClr val="1F2A2E"/>
+                </a:solidFill>
+                <a:latin typeface="Calibri"/>
+              </a:rPr>
+              <a:t>Modelo A homogêneo: AUROC de 0,950 a 0,962.</a:t>
+            </a:r>
+          </a:p>
+          <a:p>
+            <a:pPr algn="l" marL="256032" indent="-256032">
+              <a:spcAft>
+                <a:spcPts val="1000"/>
+              </a:spcAft>
+              <a:buChar char="•"/>
+            </a:pPr>
+            <a:r>
+              <a:rPr sz="1500" b="0" i="0">
+                <a:solidFill>
+                  <a:srgbClr val="1F2A2E"/>
+                </a:solidFill>
+                <a:latin typeface="Calibri"/>
+              </a:rPr>
+              <a:t>Modelo B subestima mães brancas (O/E 1,15) e o interior (O/E 1,08). No interior, o pareamento também é menor.</a:t>
+            </a:r>
+          </a:p>
+        </p:txBody>
+      </p:sp>
+    </p:spTree>
+  </p:cSld>
+  <p:clrMapOvr>
+    <a:masterClrMapping/>
+  </p:clrMapOvr>
+</p:sld>
+</file>
+
+<file path=ppt/slides/slide13.xml><?xml version="1.0" encoding="utf-8"?>
+<p:sld xmlns:a="http://schemas.openxmlformats.org/drawingml/2006/main" xmlns:p="http://schemas.openxmlformats.org/presentationml/2006/main" xmlns:r="http://schemas.openxmlformats.org/officeDocument/2006/relationships">
+  <p:cSld>
+    <p:bg>
+      <p:bgPr>
+        <a:solidFill>
+          <a:srgbClr val="FFFFFF"/>
+        </a:solidFill>
+        <a:effectLst/>
+      </p:bgPr>
+    </p:bg>
+    <p:spTree>
+      <p:nvGrpSpPr>
+        <p:cNvPr id="1" name=""/>
+        <p:cNvGrpSpPr/>
+        <p:nvPr/>
+      </p:nvGrpSpPr>
+      <p:grpSpPr/>
+      <p:sp>
+        <p:nvSpPr>
+          <p:cNvPr id="2" name="TextBox 1"/>
+          <p:cNvSpPr txBox="1"/>
+          <p:nvPr/>
+        </p:nvSpPr>
+        <p:spPr>
+          <a:xfrm>
+            <a:off x="548640" y="411480"/>
+            <a:ext cx="11094415" cy="731520"/>
+          </a:xfrm>
+          <a:prstGeom prst="rect">
+            <a:avLst/>
+          </a:prstGeom>
+          <a:noFill/>
+        </p:spPr>
+        <p:txBody>
+          <a:bodyPr wrap="square" anchor="t" lIns="0" rIns="0" tIns="0" bIns="0">
+            <a:spAutoFit/>
+          </a:bodyPr>
+          <a:lstStyle/>
+          <a:p>
+            <a:pPr algn="l">
+              <a:spcAft>
+                <a:spcPts val="600"/>
+              </a:spcAft>
+            </a:pPr>
+            <a:r>
+              <a:rPr sz="3400" b="1" i="0">
+                <a:solidFill>
+                  <a:srgbClr val="0B4F5C"/>
+                </a:solidFill>
+                <a:latin typeface="Cambria"/>
+              </a:rPr>
+              <a:t>Sensibilidade ao linkage e limitações</a:t>
             </a:r>
           </a:p>
         </p:txBody>
@@ -5192,7 +5499,7 @@
         <p:spPr>
           <a:xfrm>
             <a:off x="548640" y="1463040"/>
-            <a:ext cx="11094415" cy="1280160"/>
+            <a:ext cx="11094415" cy="1371600"/>
           </a:xfrm>
           <a:prstGeom prst="roundRect">
             <a:avLst>
@@ -5237,8 +5544,8 @@
         </p:nvSpPr>
         <p:spPr>
           <a:xfrm>
-            <a:off x="822959" y="1572768"/>
-            <a:ext cx="10545775" cy="1097280"/>
+            <a:off x="822959" y="1554480"/>
+            <a:ext cx="10545775" cy="1234440"/>
           </a:xfrm>
           <a:prstGeom prst="rect">
             <a:avLst/>
@@ -5257,22 +5564,38 @@
               </a:spcAft>
             </a:pPr>
             <a:r>
-              <a:rPr sz="1600" b="1" i="0">
+              <a:rPr sz="1500" b="1" i="0">
                 <a:solidFill>
                   <a:srgbClr val="0B4F5C"/>
                 </a:solidFill>
                 <a:latin typeface="Calibri"/>
               </a:rPr>
-              <a:t>Só as passadas 1–2 do linkage: </a:t>
-            </a:r>
-            <a:r>
-              <a:rPr sz="1600" b="0" i="0">
+              <a:t>Mesmo teste de 2023, rótulos alternativos no treino: </a:t>
+            </a:r>
+            <a:r>
+              <a:rPr sz="1500" b="0" i="0">
                 <a:solidFill>
                   <a:srgbClr val="1F2A2E"/>
                 </a:solidFill>
                 <a:latin typeface="Calibri"/>
               </a:rPr>
-              <a:t>AUROC 0,959 (A) e 0,891 (B), contra 0,956 e 0,890 com todas. Os falsos pares não explicam o desempenho.</a:t>
+              <a:t>ΔAUROC -0,0001 (estrito) e -0,0005 (pior caso), com IC que incluem 0. A discriminação é robusta,</a:t>
+            </a:r>
+          </a:p>
+          <a:p>
+            <a:pPr algn="l">
+              <a:spcAft>
+                <a:spcPts val="600"/>
+              </a:spcAft>
+            </a:pPr>
+            <a:r>
+              <a:rPr sz="1500" b="0" i="0">
+                <a:solidFill>
+                  <a:srgbClr val="1F2A2E"/>
+                </a:solidFill>
+                <a:latin typeface="Calibri"/>
+              </a:rPr>
+              <a:t>mas o O/E sobe para 1,15–1,23: a calibração depende da completude do linkage.</a:t>
             </a:r>
           </a:p>
         </p:txBody>
@@ -5359,7 +5682,7 @@
                 </a:solidFill>
                 <a:latin typeface="Calibri"/>
               </a:rPr>
-              <a:t>Óbitos não pareados</a:t>
+              <a:t>Rótulos imperfeitos</a:t>
             </a:r>
           </a:p>
         </p:txBody>
@@ -5398,7 +5721,7 @@
                 </a:solidFill>
                 <a:latin typeface="Calibri"/>
               </a:rPr>
-              <a:t>10% dos óbitos ficam rotulados como sobreviventes.</a:t>
+              <a:t>≈15% dos óbitos sem par verdadeiro; menos extremos e mais do interior.</a:t>
             </a:r>
           </a:p>
         </p:txBody>
@@ -5650,7 +5973,7 @@
                 </a:solidFill>
                 <a:latin typeface="Calibri"/>
               </a:rPr>
-              <a:t>No pré-parto usamos a IG do parto, aproximação da IG na admissão.</a:t>
+              <a:t>No modelo B é a IG do parto: vale para a admissão, não para semanas antes.</a:t>
             </a:r>
           </a:p>
         </p:txBody>
@@ -5789,7 +6112,7 @@
 </p:sld>
 </file>
 
-<file path=ppt/slides/slide13.xml><?xml version="1.0" encoding="utf-8"?>
+<file path=ppt/slides/slide14.xml><?xml version="1.0" encoding="utf-8"?>
 <p:sld xmlns:a="http://schemas.openxmlformats.org/drawingml/2006/main" xmlns:p="http://schemas.openxmlformats.org/presentationml/2006/main" xmlns:r="http://schemas.openxmlformats.org/officeDocument/2006/relationships">
   <p:cSld>
     <p:bg>
@@ -5933,7 +6256,7 @@
                 </a:solidFill>
                 <a:latin typeface="Calibri"/>
               </a:rPr>
-              <a:t>Linkage aberto e reproduzível: 90,1% dos óbitos pareados, como com dados identificados.</a:t>
+              <a:t>Linkage aberto: 90,1% pareados (≈85% verdadeiros); discriminação robusta a ele.</a:t>
             </a:r>
           </a:p>
         </p:txBody>
@@ -6117,7 +6440,7 @@
                 </a:solidFill>
                 <a:latin typeface="Calibri"/>
               </a:rPr>
-              <a:t>Antes do parto: AUROC 0,890, bem calibrado, útil para regulação.</a:t>
+              <a:t>Na admissão para o parto: AUROC 0,890 e benefício líquido positivo.</a:t>
             </a:r>
           </a:p>
         </p:txBody>
@@ -6241,7 +6564,7 @@
                 </a:solidFill>
                 <a:latin typeface="Calibri"/>
               </a:rPr>
-              <a:t>Validação externa em outras UFs · linkage probabilístico nas passadas tolerantes · óbito pós-neonatal · IG estimada no pré-natal · avaliação de impacto com gestores</a:t>
+              <a:t>Validação externa em outras UFs · etapa probabilística no linkage · completude do linkage por ano e região · recalibração periódica (drift) · avaliação de impacto com gestores</a:t>
             </a:r>
           </a:p>
         </p:txBody>
@@ -7998,7 +8321,7 @@
                 </a:solidFill>
                 <a:latin typeface="Calibri"/>
               </a:rPr>
-              <a:t>H3: pior na baixa escolaridade</a:t>
+              <a:t>H3: calibração pior na baixa escolaridade</a:t>
             </a:r>
           </a:p>
         </p:txBody>
@@ -9136,11 +9459,11 @@
             <a:r>
               <a:rPr sz="3400" b="1" i="0">
                 <a:solidFill>
-                  <a:srgbClr val="5F6B70"/>
+                  <a:srgbClr val="E85D3F"/>
                 </a:solidFill>
                 <a:latin typeface="Cambria"/>
               </a:rPr>
-              <a:t>90,8%</a:t>
+              <a:t>≈85%</a:t>
             </a:r>
           </a:p>
         </p:txBody>
@@ -9179,7 +9502,7 @@
                 </a:solidFill>
                 <a:latin typeface="Calibri"/>
               </a:rPr>
-              <a:t>Maia et al. (2017), com dados identificados</a:t>
+              <a:t>com par verdadeiro, descontados os falsos pares</a:t>
             </a:r>
           </a:p>
         </p:txBody>
@@ -9242,7 +9565,7 @@
                 </a:solidFill>
                 <a:latin typeface="Calibri"/>
               </a:rPr>
-              <a:t>Falsos pares estimados nas passadas 1–2 (que somam 82% dos pares): até 8%. As passadas tolerantes chegam a 32% e são testadas na análise de sensibilidade.</a:t>
+              <a:t>Falsos pares estimados nas passadas 1–2 (que somam 82% dos pares): até 8%. As passadas tolerantes chegam a 32%. Pareamento: 94,3% na capital, 88,0% no interior. Óbitos sem peso na DO quase não pareiam.</a:t>
             </a:r>
           </a:p>
         </p:txBody>

</xml_diff>

<commit_message>
2ª revisão do parecer + explicabilidade (XAI)
- XAI (src/explicabilidade.py): SHAP exato com verificação de aditividade, dependência,
  explicações locais (VP/FN/FP), estabilidade XGBoost × LightGBM e atributos sensíveis
- Corrige SHAP para usar só as árvores da melhor iteração (early stopping), com teste
- Completude do linkage por ano × região: não explica o O/E do interior
- Teste com rótulos estritos: pares tolerantes não inflam a AUROC
- Curva de calibração junto à curva de decisão; faixa clínica 2–10% justificada;
  isotônica piorou o O/E no teste (reportado); drift como explicação plausível
- Abstract em formato numérico inglês; frases de robustez e perfil dos não pareados
  corrigidas; raça da mãe × do recém-nascido explicitada; DOI do TRIPOD+AI
- Slides: 2 slides de XAI, notas revisadas (~14 min); roteiro de arguição atualizado

Co-Authored-By: Claude Opus 5.5 (1M context) <noreply@anthropic.com>
</commit_message>
<xml_diff>
--- a/slides/apresentacao.pptx
+++ b/slides/apresentacao.pptx
@@ -19,6 +19,8 @@
     <p:sldId id="267" r:id="rId19"/>
     <p:sldId id="268" r:id="rId20"/>
     <p:sldId id="269" r:id="rId21"/>
+    <p:sldId id="270" r:id="rId22"/>
+    <p:sldId id="271" r:id="rId23"/>
   </p:sldIdLst>
   <p:sldSz cx="12191695" cy="6858000" type="screen4x3"/>
   <p:notesSz cx="6858000" cy="9144000"/>
@@ -655,7 +657,7 @@
           <a:lstStyle/>
           <a:p>
             <a:r>
-              <a:t>A pergunta mais provável é se os erros do linkage explicam os resultados. Para testar, reajustei o modelo com rótulos alternativos no treino, avaliando sempre no mesmo teste de 2023. No cenário estrito, removi os pares duvidosos. No pior caso, marquei-os como sobreviventes. A AUROC mudou -0,0001 e -0,0005, com intervalos que incluem zero. A discriminação é robusta. Mas o O/E sobe para até 1,23: a calibração absoluta depende da completude do linkage. As limitações principais são os rótulos imperfeitos, a falta de validação externa e o uso de variáveis do pós-parto no modelo A.</a:t>
+              <a:t>A pergunta mais provável é se os erros do linkage explicam os resultados. Para testar, reajustei o modelo com rótulos alternativos no treino, avaliando sempre no mesmo teste de 2023. No cenário estrito, removi os pares duvidosos. No pior caso, marquei-os como sobreviventes. A AUROC mudou -0,0001 e -0,0005, com intervalos que incluem zero: o modelo é robusto a ruído de rótulo no treino. No teste, sem os pares duvidosos, a AUROC fica em 0,959, então eles não inflam o resultado. Os óbitos que ficaram sem par, esses sim, não podem ser avaliados. Já o O/E sobe para até 1,23: a calibração absoluta depende da completude do linkage. As limitações principais são os rótulos imperfeitos, a falta de validação externa e o uso de variáveis do pós-parto no modelo A.</a:t>
             </a:r>
           </a:p>
         </p:txBody>
@@ -725,7 +727,7 @@
           <a:lstStyle/>
           <a:p>
             <a:r>
-              <a:t>Para concluir. Primeiro, dá para reproduzir o resultado do artigo com dados totalmente abertos, e a discriminação é robusta aos erros do linkage. Segundo, a calibração absoluta não é: depende da completude do linkage e do drift temporal, então um uso real exigiria recalibração periódica. Terceiro, o modelo na admissão para o parto tem desempenho útil para decisões de transferência. Como próximos passos: validar em outros estados, acrescentar uma etapa probabilística ao linkage e avaliar o impacto com gestores. O código e os dados de reprodução estão no repositório. Obrigado.</a:t>
+              <a:t>Para concluir. Primeiro, dá para reproduzir o resultado do artigo com dados totalmente abertos, e a discriminação é robusta a ruído de rótulo no treino. As explicações SHAP são aditivas, estáveis e plausíveis. Segundo, a calibração absoluta não é: depende da completude do linkage e do drift temporal, então um uso real exigiria recalibração periódica. Terceiro, o modelo na admissão para o parto tem desempenho útil para decisões de transferência. Como próximos passos: validar em outros estados, acrescentar uma etapa probabilística ao linkage e avaliar o impacto com gestores. O código e os dados de reprodução estão no repositório. Obrigado.</a:t>
             </a:r>
           </a:p>
         </p:txBody>
@@ -795,7 +797,7 @@
           <a:lstStyle/>
           <a:p>
             <a:r>
-              <a:t>Calibração e utilidade clínica. A inclinação de calibração é 0,98 no A e 0,99 no B, praticamente 1, então as previsões não são extremas demais. O intercepto do B é 0,063, que é exatamente o logaritmo de 8,20 sobre 7,70: a mortalidade subiu em 2023. É drift de prevalência, não defeito do modelo. Em uso real, o intercepto precisaria ser recalibrado periodicamente. A curva de decisão mostra benefício líquido acima de tratar todos e de tratar nenhum em todos os limiares de 1% a 20%. Esta é a métrica que diz se o modelo ajuda a decidir.</a:t>
+              <a:t>Agora a explicabilidade. Usei SHAP, que decompõe o log-odds de cada nascimento em contribuições aditivas. Primeiro verifiquei a aditividade: a soma reproduz a predição com erro menor que 1e-5. Isso expôs uma armadilha: com early stopping, o XGBoost usa por padrão todas as árvores, inclusive as posteriores à melhor iteração, e o SHAP explicaria outro modelo. Nos gráficos de dependência, os efeitos são clinicamente plausíveis: o risco cai com Apgar, peso e idade gestacional, e sobe com a idade materna acima de 38 anos. As consultas de pré-natal têm forma de U: acima de 14 consultas, o risco sobe. Isso é confusão por indicação, porque gestações de alto risco são mais acompanhadas. Então o SHAP mostra associação no modelo, não causa.</a:t>
             </a:r>
           </a:p>
         </p:txBody>
@@ -865,7 +867,147 @@
           <a:lstStyle/>
           <a:p>
             <a:r>
-              <a:t>Subgrupos e H3. A hipótese era calibração pior na baixa escolaridade. O O/E nesse grupo foi 1,06, com intervalo que inclui 1 e se sobrepõe ao do ensino superior. Então H3 não se confirmou, e prefiro dizer isso claramente a trocar a hipótese depois de ver os dados. O modelo completo é homogêneo. O pré-parto subestima o risco para mães brancas e para o interior. No interior há uma explicação alternativa: o pareamento é menor lá. Para raça/cor, o pareamento é quase igual entre os grupos, então o linkage não explica.</a:t>
+              <a:t>As explicações locais mostram três casos. O óbito bem previsto tinha 374 gramas e Apgar zero. O óbito que o modelo não sinalizou tinha Apgar 5 e 7 e 2,2 quilos: um recém-nascido de risco moderado, que a DN não distingue de sobreviventes parecidos. O falso positivo tinha Apgar 1 e 1 e anomalia, e sobreviveu. Ou seja, os erros vêm de falta de informação na DN, não de efeitos espúrios. As explicações são estáveis: o ranking do XGBoost e do LightGBM tem correlação de 0,96, e entre metades da amostra, 0,999. No modelo pré-parto, raça e escolaridade pesam cerca de 8%: o modelo usa o gradiente socioeconômico no lugar do estado do recém-nascido, o que ajuda a entender a subestimação para mães brancas.</a:t>
+            </a:r>
+          </a:p>
+        </p:txBody>
+      </p:sp>
+      <p:sp>
+        <p:nvSpPr>
+          <p:cNvPr id="4" name="Slide Number Placeholder 3"/>
+          <p:cNvSpPr>
+            <a:spLocks noGrp="1"/>
+          </p:cNvSpPr>
+          <p:nvPr>
+            <p:ph type="sldNum" idx="5" sz="quarter"/>
+          </p:nvPr>
+        </p:nvSpPr>
+        <p:spPr/>
+      </p:sp>
+    </p:spTree>
+  </p:cSld>
+  <p:clrMapOvr>
+    <a:masterClrMapping/>
+  </p:clrMapOvr>
+</p:notes>
+</file>
+
+<file path=ppt/notesSlides/notesSlide15.xml><?xml version="1.0" encoding="utf-8"?>
+<p:notes xmlns:a="http://schemas.openxmlformats.org/drawingml/2006/main" xmlns:p="http://schemas.openxmlformats.org/presentationml/2006/main" xmlns:r="http://schemas.openxmlformats.org/officeDocument/2006/relationships">
+  <p:cSld>
+    <p:spTree>
+      <p:nvGrpSpPr>
+        <p:cNvPr id="1" name=""/>
+        <p:cNvGrpSpPr/>
+        <p:nvPr/>
+      </p:nvGrpSpPr>
+      <p:grpSpPr>
+        <a:xfrm>
+          <a:off x="0" y="0"/>
+          <a:ext cx="0" cy="0"/>
+          <a:chOff x="0" y="0"/>
+          <a:chExt cx="0" cy="0"/>
+        </a:xfrm>
+      </p:grpSpPr>
+      <p:sp>
+        <p:nvSpPr>
+          <p:cNvPr id="2" name="Slide Image Placeholder 1"/>
+          <p:cNvSpPr>
+            <a:spLocks noGrp="1"/>
+          </p:cNvSpPr>
+          <p:nvPr>
+            <p:ph type="sldImg" idx="2"/>
+          </p:nvPr>
+        </p:nvSpPr>
+        <p:spPr/>
+      </p:sp>
+      <p:sp>
+        <p:nvSpPr>
+          <p:cNvPr id="3" name="Notes Placeholder 2"/>
+          <p:cNvSpPr>
+            <a:spLocks noGrp="1"/>
+          </p:cNvSpPr>
+          <p:nvPr>
+            <p:ph type="body" idx="3" sz="quarter"/>
+          </p:nvPr>
+        </p:nvSpPr>
+        <p:spPr/>
+        <p:txBody>
+          <a:bodyPr/>
+          <a:lstStyle/>
+          <a:p>
+            <a:r>
+              <a:t>A curva de calibração acompanha a diagonal, e as inclinações são próximas de 1. Um achado honesto: a recalibração isotônica, ajustada em 2022, piorou um pouco o O/E no teste, de 0,99 para 1,02 no modelo A. A explicação plausível é o drift: a mortalidade subiu em 2023, e parte disso vem da completude do linkage, que também subiu. Na curva de decisão, tratar todos é negativo para qualquer limiar acima da prevalência, então superá-lo é trivial; a comparação que importa é com não intervir. Escolhi a faixa de 2 a 10% pelo uso clínico: para uma transferência in utero, é razoável aceitar entre 9 e 49 falsos alarmes por óbito identificado. Nessa faixa, o benefício líquido é sempre positivo nos dois modelos.</a:t>
+            </a:r>
+          </a:p>
+        </p:txBody>
+      </p:sp>
+      <p:sp>
+        <p:nvSpPr>
+          <p:cNvPr id="4" name="Slide Number Placeholder 3"/>
+          <p:cNvSpPr>
+            <a:spLocks noGrp="1"/>
+          </p:cNvSpPr>
+          <p:nvPr>
+            <p:ph type="sldNum" idx="5" sz="quarter"/>
+          </p:nvPr>
+        </p:nvSpPr>
+        <p:spPr/>
+      </p:sp>
+    </p:spTree>
+  </p:cSld>
+  <p:clrMapOvr>
+    <a:masterClrMapping/>
+  </p:clrMapOvr>
+</p:notes>
+</file>
+
+<file path=ppt/notesSlides/notesSlide16.xml><?xml version="1.0" encoding="utf-8"?>
+<p:notes xmlns:a="http://schemas.openxmlformats.org/drawingml/2006/main" xmlns:p="http://schemas.openxmlformats.org/presentationml/2006/main" xmlns:r="http://schemas.openxmlformats.org/officeDocument/2006/relationships">
+  <p:cSld>
+    <p:spTree>
+      <p:nvGrpSpPr>
+        <p:cNvPr id="1" name=""/>
+        <p:cNvGrpSpPr/>
+        <p:nvPr/>
+      </p:nvGrpSpPr>
+      <p:grpSpPr>
+        <a:xfrm>
+          <a:off x="0" y="0"/>
+          <a:ext cx="0" cy="0"/>
+          <a:chOff x="0" y="0"/>
+          <a:chExt cx="0" cy="0"/>
+        </a:xfrm>
+      </p:grpSpPr>
+      <p:sp>
+        <p:nvSpPr>
+          <p:cNvPr id="2" name="Slide Image Placeholder 1"/>
+          <p:cNvSpPr>
+            <a:spLocks noGrp="1"/>
+          </p:cNvSpPr>
+          <p:nvPr>
+            <p:ph type="sldImg" idx="2"/>
+          </p:nvPr>
+        </p:nvSpPr>
+        <p:spPr/>
+      </p:sp>
+      <p:sp>
+        <p:nvSpPr>
+          <p:cNvPr id="3" name="Notes Placeholder 2"/>
+          <p:cNvSpPr>
+            <a:spLocks noGrp="1"/>
+          </p:cNvSpPr>
+          <p:nvPr>
+            <p:ph type="body" idx="3" sz="quarter"/>
+          </p:nvPr>
+        </p:nvSpPr>
+        <p:spPr/>
+        <p:txBody>
+          <a:bodyPr/>
+          <a:lstStyle/>
+          <a:p>
+            <a:r>
+              <a:t>Subgrupos e H3. A hipótese era calibração pior na baixa escolaridade. O O/E nesse grupo foi 1,06, com intervalo que inclui 1, então H3 não se confirmou. O modelo completo é homogêneo. O pré-parto subestima o risco para mães brancas e para o interior. Testei se o linkage explica o interior: a completude é estável ao longo dos anos e subiu igualmente nas duas regiões em 2023. Então não explica, e restam fatores regionais. Para mães brancas, o pareamento é quase igual por raça, mas essa evidência é indireta, porque a DO informa a raça do recém-nascido, e não a da mãe.</a:t>
             </a:r>
           </a:p>
         </p:txBody>
@@ -1425,7 +1567,7 @@
           <a:lstStyle/>
           <a:p>
             <a:r>
-              <a:t>Nas curvas, as linhas cheias são o modelo completo e as tracejadas, o pré-parto. Os três algoritmos quase se sobrepõem. À direita está a métrica operacional: priorizando 5% dos nascimentos, o modelo completo captura 87% dos óbitos e o pré-parto, 72%. Ramos e colegas, em 2025, com dados nacionais, encontraram mais de 85%, o que é coerente. A diferença para os 90% do artigo é compatível com os óbitos sem par verdadeiro, que são menos extremos e mais difíceis, e com a heterogeneidade do estado.</a:t>
+              <a:t>Nas curvas, as linhas cheias são o modelo completo e as tracejadas, o pré-parto. Os três algoritmos quase se sobrepõem. À direita está a métrica operacional: priorizando 5% dos nascimentos, o modelo completo captura 87% dos óbitos e o pré-parto, 72%. Ramos e colegas, em 2025, com dados nacionais, encontraram mais de 85%, o que é coerente. A diferença para os 90% do artigo é compatível com os óbitos sem par verdadeiro, que têm outro perfil (mais campos ausentes, mais do interior, mais óbitos precoces fora do hospital), e com a heterogeneidade do estado.</a:t>
             </a:r>
           </a:p>
         </p:txBody>
@@ -5072,7 +5214,7 @@
                 </a:solidFill>
                 <a:latin typeface="Cambria"/>
               </a:rPr>
-              <a:t>Calibração e utilidade clínica</a:t>
+              <a:t>Explicabilidade: o que o modelo aprendeu</a:t>
             </a:r>
           </a:p>
         </p:txBody>
@@ -5111,14 +5253,14 @@
                 </a:solidFill>
                 <a:latin typeface="Calibri"/>
               </a:rPr>
-              <a:t>XGBoost recalibrado, teste de 2023</a:t>
+              <a:t>SHAP exato (TreeSHAP) em 20 mil nascimentos de 2023</a:t>
             </a:r>
           </a:p>
         </p:txBody>
       </p:sp>
       <p:pic>
         <p:nvPicPr>
-          <p:cNvPr id="4" name="Picture 3" descr="curva_decisao.png"/>
+          <p:cNvPr id="4" name="Picture 3" descr="xai_dependencia.png"/>
           <p:cNvPicPr>
             <a:picLocks noChangeAspect="1"/>
           </p:cNvPicPr>
@@ -5132,8 +5274,8 @@
         </p:blipFill>
         <p:spPr>
           <a:xfrm>
-            <a:off x="548640" y="1554480"/>
-            <a:ext cx="7132320" cy="3231762"/>
+            <a:off x="548640" y="1600200"/>
+            <a:ext cx="7406640" cy="3739011"/>
           </a:xfrm>
           <a:prstGeom prst="rect">
             <a:avLst/>
@@ -5148,8 +5290,8 @@
         </p:nvSpPr>
         <p:spPr>
           <a:xfrm>
-            <a:off x="7955279" y="1645920"/>
-            <a:ext cx="3749039" cy="4846320"/>
+            <a:off x="8229600" y="1554480"/>
+            <a:ext cx="3566160" cy="4937760"/>
           </a:xfrm>
           <a:prstGeom prst="rect">
             <a:avLst/>
@@ -5169,13 +5311,22 @@
               <a:buChar char="•"/>
             </a:pPr>
             <a:r>
-              <a:rPr sz="1500" b="0" i="0">
+              <a:rPr sz="1400" b="1" i="0">
+                <a:solidFill>
+                  <a:srgbClr val="0B4F5C"/>
+                </a:solidFill>
+                <a:latin typeface="Calibri"/>
+              </a:rPr>
+              <a:t>Verificado: </a:t>
+            </a:r>
+            <a:r>
+              <a:rPr sz="1400" b="0" i="0">
                 <a:solidFill>
                   <a:srgbClr val="1F2A2E"/>
                 </a:solidFill>
                 <a:latin typeface="Calibri"/>
               </a:rPr>
-              <a:t>Inclinação de calibração: 0,98 (A) e 0,99 (B), ideal 1.</a:t>
+              <a:t>φ0 + Σφ reproduz o log-odds (erro &lt; 1e-5), usando só as árvores da melhor iteração.</a:t>
             </a:r>
           </a:p>
           <a:p>
@@ -5186,13 +5337,13 @@
               <a:buChar char="•"/>
             </a:pPr>
             <a:r>
-              <a:rPr sz="1500" b="0" i="0">
+              <a:rPr sz="1400" b="0" i="0">
                 <a:solidFill>
                   <a:srgbClr val="1F2A2E"/>
                 </a:solidFill>
                 <a:latin typeface="Calibri"/>
               </a:rPr>
-              <a:t>Intercepto de B: 0,063 ≈ ln(8,20/7,70). É o aumento da TMN em 2023 (drift).</a:t>
+              <a:t>Apgar, peso e IG: risco cai de forma monotônica, como esperado.</a:t>
             </a:r>
           </a:p>
           <a:p>
@@ -5203,13 +5354,39 @@
               <a:buChar char="•"/>
             </a:pPr>
             <a:r>
-              <a:rPr sz="1500" b="0" i="0">
+              <a:rPr sz="1400" b="0" i="0">
                 <a:solidFill>
                   <a:srgbClr val="1F2A2E"/>
                 </a:solidFill>
                 <a:latin typeface="Calibri"/>
               </a:rPr>
-              <a:t>Benefício líquido acima de tratar todos/nenhum de 1% a 20%. Com pt = 5%: 5,6 por mil, sinalizando 1,9% dos nascimentos.</a:t>
+              <a:t>Idade da mãe &gt; 38 anos aumenta o risco (modelo B).</a:t>
+            </a:r>
+          </a:p>
+          <a:p>
+            <a:pPr algn="l" marL="256032" indent="-256032">
+              <a:spcAft>
+                <a:spcPts val="1000"/>
+              </a:spcAft>
+              <a:buChar char="•"/>
+            </a:pPr>
+            <a:r>
+              <a:rPr sz="1400" b="1" i="0">
+                <a:solidFill>
+                  <a:srgbClr val="0B4F5C"/>
+                </a:solidFill>
+                <a:latin typeface="Calibri"/>
+              </a:rPr>
+              <a:t>Consultas em U: </a:t>
+            </a:r>
+            <a:r>
+              <a:rPr sz="1400" b="0" i="0">
+                <a:solidFill>
+                  <a:srgbClr val="1F2A2E"/>
+                </a:solidFill>
+                <a:latin typeface="Calibri"/>
+              </a:rPr>
+              <a:t>mais de 14 consultas aumenta o risco, confusão por indicação. SHAP é associação, não causa.</a:t>
             </a:r>
           </a:p>
         </p:txBody>
@@ -5274,53 +5451,14 @@
                 </a:solidFill>
                 <a:latin typeface="Cambria"/>
               </a:rPr>
-              <a:t>Subgrupos e H3</a:t>
-            </a:r>
-          </a:p>
-        </p:txBody>
-      </p:sp>
-      <p:sp>
-        <p:nvSpPr>
-          <p:cNvPr id="3" name="TextBox 2"/>
-          <p:cNvSpPr txBox="1"/>
-          <p:nvPr/>
-        </p:nvSpPr>
-        <p:spPr>
-          <a:xfrm>
-            <a:off x="548640" y="1097280"/>
-            <a:ext cx="11094415" cy="411480"/>
-          </a:xfrm>
-          <a:prstGeom prst="rect">
-            <a:avLst/>
-          </a:prstGeom>
-          <a:noFill/>
-        </p:spPr>
-        <p:txBody>
-          <a:bodyPr wrap="square" anchor="t" lIns="0" rIns="0" tIns="0" bIns="0">
-            <a:spAutoFit/>
-          </a:bodyPr>
-          <a:lstStyle/>
-          <a:p>
-            <a:pPr algn="l">
-              <a:spcAft>
-                <a:spcPts val="600"/>
-              </a:spcAft>
-            </a:pPr>
-            <a:r>
-              <a:rPr sz="1600" b="0" i="1">
-                <a:solidFill>
-                  <a:srgbClr val="5F6B70"/>
-                </a:solidFill>
-                <a:latin typeface="Calibri"/>
-              </a:rPr>
-              <a:t>IC 95% por bootstrap dentro de cada subgrupo</a:t>
+              <a:t>Explicações locais e estabilidade</a:t>
             </a:r>
           </a:p>
         </p:txBody>
       </p:sp>
       <p:pic>
         <p:nvPicPr>
-          <p:cNvPr id="4" name="Picture 3" descr="subgrupos.png"/>
+          <p:cNvPr id="3" name="Picture 2" descr="xai_local.png"/>
           <p:cNvPicPr>
             <a:picLocks noChangeAspect="1"/>
           </p:cNvPicPr>
@@ -5334,8 +5472,8 @@
         </p:blipFill>
         <p:spPr>
           <a:xfrm>
-            <a:off x="548640" y="1463040"/>
-            <a:ext cx="7498079" cy="3565652"/>
+            <a:off x="548640" y="1188720"/>
+            <a:ext cx="11094415" cy="3034960"/>
           </a:xfrm>
           <a:prstGeom prst="rect">
             <a:avLst/>
@@ -5344,14 +5482,14 @@
       </p:pic>
       <p:sp>
         <p:nvSpPr>
-          <p:cNvPr id="5" name="TextBox 4"/>
+          <p:cNvPr id="4" name="TextBox 3"/>
           <p:cNvSpPr txBox="1"/>
           <p:nvPr/>
         </p:nvSpPr>
         <p:spPr>
           <a:xfrm>
-            <a:off x="8229600" y="1645920"/>
-            <a:ext cx="3474720" cy="4754880"/>
+            <a:off x="548640" y="4434840"/>
+            <a:ext cx="11094415" cy="2194560"/>
           </a:xfrm>
           <a:prstGeom prst="rect">
             <a:avLst/>
@@ -5371,22 +5509,13 @@
               <a:buChar char="•"/>
             </a:pPr>
             <a:r>
-              <a:rPr sz="1500" b="1" i="0">
-                <a:solidFill>
-                  <a:srgbClr val="0B4F5C"/>
+              <a:rPr sz="1400" b="0" i="0">
+                <a:solidFill>
+                  <a:srgbClr val="1F2A2E"/>
                 </a:solidFill>
                 <a:latin typeface="Calibri"/>
               </a:rPr>
-              <a:t>H3 não confirmada: </a:t>
-            </a:r>
-            <a:r>
-              <a:rPr sz="1500" b="0" i="0">
-                <a:solidFill>
-                  <a:srgbClr val="1F2A2E"/>
-                </a:solidFill>
-                <a:latin typeface="Calibri"/>
-              </a:rPr>
-              <a:t>O/E na baixa escolaridade 1,06 (IC 0,97–1,16), que inclui 1.</a:t>
+              <a:t>Os erros ocorrem onde a DN tem pouca informação: o óbito não sinalizado tinha Apgar 5/7 e 2.232 g; o falso positivo, Apgar 1/1 com anomalia, sobreviveu.</a:t>
             </a:r>
           </a:p>
           <a:p>
@@ -5397,13 +5526,13 @@
               <a:buChar char="•"/>
             </a:pPr>
             <a:r>
-              <a:rPr sz="1500" b="0" i="0">
+              <a:rPr sz="1400" b="0" i="0">
                 <a:solidFill>
                   <a:srgbClr val="1F2A2E"/>
                 </a:solidFill>
                 <a:latin typeface="Calibri"/>
               </a:rPr>
-              <a:t>Modelo A homogêneo: AUROC de 0,950 a 0,962.</a:t>
+              <a:t>Ranking estável: Spearman XGBoost × LightGBM de 0,96 (A) e 0,89 (B); entre metades da amostra, 0,999.</a:t>
             </a:r>
           </a:p>
           <a:p>
@@ -5414,13 +5543,13 @@
               <a:buChar char="•"/>
             </a:pPr>
             <a:r>
-              <a:rPr sz="1500" b="0" i="0">
+              <a:rPr sz="1400" b="0" i="0">
                 <a:solidFill>
                   <a:srgbClr val="1F2A2E"/>
                 </a:solidFill>
                 <a:latin typeface="Calibri"/>
               </a:rPr>
-              <a:t>Modelo B subestima mães brancas (O/E 1,15) e o interior (O/E 1,08). No interior, o pareamento também é menor.</a:t>
+              <a:t>Raça/cor e escolaridade da mãe respondem por 8,1% da importância no modelo B: é o gradiente socioeconômico substituindo o estado do recém-nascido.</a:t>
             </a:r>
           </a:p>
         </p:txBody>
@@ -5485,6 +5614,436 @@
                 </a:solidFill>
                 <a:latin typeface="Cambria"/>
               </a:rPr>
+              <a:t>Calibração e utilidade clínica</a:t>
+            </a:r>
+          </a:p>
+        </p:txBody>
+      </p:sp>
+      <p:sp>
+        <p:nvSpPr>
+          <p:cNvPr id="3" name="TextBox 2"/>
+          <p:cNvSpPr txBox="1"/>
+          <p:nvPr/>
+        </p:nvSpPr>
+        <p:spPr>
+          <a:xfrm>
+            <a:off x="548640" y="1097280"/>
+            <a:ext cx="11094415" cy="411480"/>
+          </a:xfrm>
+          <a:prstGeom prst="rect">
+            <a:avLst/>
+          </a:prstGeom>
+          <a:noFill/>
+        </p:spPr>
+        <p:txBody>
+          <a:bodyPr wrap="square" anchor="t" lIns="0" rIns="0" tIns="0" bIns="0">
+            <a:spAutoFit/>
+          </a:bodyPr>
+          <a:lstStyle/>
+          <a:p>
+            <a:pPr algn="l">
+              <a:spcAft>
+                <a:spcPts val="600"/>
+              </a:spcAft>
+            </a:pPr>
+            <a:r>
+              <a:rPr sz="1600" b="0" i="1">
+                <a:solidFill>
+                  <a:srgbClr val="5F6B70"/>
+                </a:solidFill>
+                <a:latin typeface="Calibri"/>
+              </a:rPr>
+              <a:t>XGBoost, teste de 2023</a:t>
+            </a:r>
+          </a:p>
+        </p:txBody>
+      </p:sp>
+      <p:pic>
+        <p:nvPicPr>
+          <p:cNvPr id="4" name="Picture 3" descr="calibracao_decisao.png"/>
+          <p:cNvPicPr>
+            <a:picLocks noChangeAspect="1"/>
+          </p:cNvPicPr>
+          <p:nvPr/>
+        </p:nvPicPr>
+        <p:blipFill>
+          <a:blip r:embed="rId2"/>
+          <a:stretch>
+            <a:fillRect/>
+          </a:stretch>
+        </p:blipFill>
+        <p:spPr>
+          <a:xfrm>
+            <a:off x="2438247" y="1554480"/>
+            <a:ext cx="7315200" cy="2804160"/>
+          </a:xfrm>
+          <a:prstGeom prst="rect">
+            <a:avLst/>
+          </a:prstGeom>
+        </p:spPr>
+      </p:pic>
+      <p:sp>
+        <p:nvSpPr>
+          <p:cNvPr id="5" name="TextBox 4"/>
+          <p:cNvSpPr txBox="1"/>
+          <p:nvPr/>
+        </p:nvSpPr>
+        <p:spPr>
+          <a:xfrm>
+            <a:off x="548640" y="4434840"/>
+            <a:ext cx="11094415" cy="2194560"/>
+          </a:xfrm>
+          <a:prstGeom prst="rect">
+            <a:avLst/>
+          </a:prstGeom>
+          <a:noFill/>
+        </p:spPr>
+        <p:txBody>
+          <a:bodyPr wrap="square" anchor="t" lIns="0" rIns="0" tIns="0" bIns="0">
+            <a:spAutoFit/>
+          </a:bodyPr>
+          <a:lstStyle/>
+          <a:p>
+            <a:pPr algn="l" marL="256032" indent="-256032">
+              <a:spcAft>
+                <a:spcPts val="1000"/>
+              </a:spcAft>
+              <a:buChar char="•"/>
+            </a:pPr>
+            <a:r>
+              <a:rPr sz="1400" b="0" i="0">
+                <a:solidFill>
+                  <a:srgbClr val="1F2A2E"/>
+                </a:solidFill>
+                <a:latin typeface="Calibri"/>
+              </a:rPr>
+              <a:t>Curva próxima da diagonal; inclinação 0,98 (A) e 0,99 (B). A isotônica piorou um pouco o O/E no teste (0,99 → 1,02 em A): drift de 2022 para 2023 é a explicação plausível.</a:t>
+            </a:r>
+          </a:p>
+          <a:p>
+            <a:pPr algn="l" marL="256032" indent="-256032">
+              <a:spcAft>
+                <a:spcPts val="1000"/>
+              </a:spcAft>
+              <a:buChar char="•"/>
+            </a:pPr>
+            <a:r>
+              <a:rPr sz="1400" b="0" i="0">
+                <a:solidFill>
+                  <a:srgbClr val="1F2A2E"/>
+                </a:solidFill>
+                <a:latin typeface="Calibri"/>
+              </a:rPr>
+              <a:t>Tratar todos é negativo acima de 0,8%, então a comparação que importa é com não intervir.</a:t>
+            </a:r>
+          </a:p>
+          <a:p>
+            <a:pPr algn="l" marL="256032" indent="-256032">
+              <a:spcAft>
+                <a:spcPts val="1000"/>
+              </a:spcAft>
+              <a:buChar char="•"/>
+            </a:pPr>
+            <a:r>
+              <a:rPr sz="1400" b="0" i="0">
+                <a:solidFill>
+                  <a:srgbClr val="1F2A2E"/>
+                </a:solidFill>
+                <a:latin typeface="Calibri"/>
+              </a:rPr>
+              <a:t>Faixa clínica 2–10% (9 a 49 falsos alarmes por óbito): benefício de 6,2–4,9 por mil (A) e 5,0–3,6 (B).</a:t>
+            </a:r>
+          </a:p>
+        </p:txBody>
+      </p:sp>
+    </p:spTree>
+  </p:cSld>
+  <p:clrMapOvr>
+    <a:masterClrMapping/>
+  </p:clrMapOvr>
+</p:sld>
+</file>
+
+<file path=ppt/slides/slide14.xml><?xml version="1.0" encoding="utf-8"?>
+<p:sld xmlns:a="http://schemas.openxmlformats.org/drawingml/2006/main" xmlns:p="http://schemas.openxmlformats.org/presentationml/2006/main" xmlns:r="http://schemas.openxmlformats.org/officeDocument/2006/relationships">
+  <p:cSld>
+    <p:bg>
+      <p:bgPr>
+        <a:solidFill>
+          <a:srgbClr val="FFFFFF"/>
+        </a:solidFill>
+        <a:effectLst/>
+      </p:bgPr>
+    </p:bg>
+    <p:spTree>
+      <p:nvGrpSpPr>
+        <p:cNvPr id="1" name=""/>
+        <p:cNvGrpSpPr/>
+        <p:nvPr/>
+      </p:nvGrpSpPr>
+      <p:grpSpPr/>
+      <p:sp>
+        <p:nvSpPr>
+          <p:cNvPr id="2" name="TextBox 1"/>
+          <p:cNvSpPr txBox="1"/>
+          <p:nvPr/>
+        </p:nvSpPr>
+        <p:spPr>
+          <a:xfrm>
+            <a:off x="548640" y="411480"/>
+            <a:ext cx="11094415" cy="731520"/>
+          </a:xfrm>
+          <a:prstGeom prst="rect">
+            <a:avLst/>
+          </a:prstGeom>
+          <a:noFill/>
+        </p:spPr>
+        <p:txBody>
+          <a:bodyPr wrap="square" anchor="t" lIns="0" rIns="0" tIns="0" bIns="0">
+            <a:spAutoFit/>
+          </a:bodyPr>
+          <a:lstStyle/>
+          <a:p>
+            <a:pPr algn="l">
+              <a:spcAft>
+                <a:spcPts val="600"/>
+              </a:spcAft>
+            </a:pPr>
+            <a:r>
+              <a:rPr sz="3400" b="1" i="0">
+                <a:solidFill>
+                  <a:srgbClr val="0B4F5C"/>
+                </a:solidFill>
+                <a:latin typeface="Cambria"/>
+              </a:rPr>
+              <a:t>Subgrupos e H3</a:t>
+            </a:r>
+          </a:p>
+        </p:txBody>
+      </p:sp>
+      <p:sp>
+        <p:nvSpPr>
+          <p:cNvPr id="3" name="TextBox 2"/>
+          <p:cNvSpPr txBox="1"/>
+          <p:nvPr/>
+        </p:nvSpPr>
+        <p:spPr>
+          <a:xfrm>
+            <a:off x="548640" y="1097280"/>
+            <a:ext cx="11094415" cy="411480"/>
+          </a:xfrm>
+          <a:prstGeom prst="rect">
+            <a:avLst/>
+          </a:prstGeom>
+          <a:noFill/>
+        </p:spPr>
+        <p:txBody>
+          <a:bodyPr wrap="square" anchor="t" lIns="0" rIns="0" tIns="0" bIns="0">
+            <a:spAutoFit/>
+          </a:bodyPr>
+          <a:lstStyle/>
+          <a:p>
+            <a:pPr algn="l">
+              <a:spcAft>
+                <a:spcPts val="600"/>
+              </a:spcAft>
+            </a:pPr>
+            <a:r>
+              <a:rPr sz="1600" b="0" i="1">
+                <a:solidFill>
+                  <a:srgbClr val="5F6B70"/>
+                </a:solidFill>
+                <a:latin typeface="Calibri"/>
+              </a:rPr>
+              <a:t>IC 95% por bootstrap dentro de cada subgrupo</a:t>
+            </a:r>
+          </a:p>
+        </p:txBody>
+      </p:sp>
+      <p:pic>
+        <p:nvPicPr>
+          <p:cNvPr id="4" name="Picture 3" descr="subgrupos.png"/>
+          <p:cNvPicPr>
+            <a:picLocks noChangeAspect="1"/>
+          </p:cNvPicPr>
+          <p:nvPr/>
+        </p:nvPicPr>
+        <p:blipFill>
+          <a:blip r:embed="rId2"/>
+          <a:stretch>
+            <a:fillRect/>
+          </a:stretch>
+        </p:blipFill>
+        <p:spPr>
+          <a:xfrm>
+            <a:off x="548640" y="1463040"/>
+            <a:ext cx="7498079" cy="3565652"/>
+          </a:xfrm>
+          <a:prstGeom prst="rect">
+            <a:avLst/>
+          </a:prstGeom>
+        </p:spPr>
+      </p:pic>
+      <p:sp>
+        <p:nvSpPr>
+          <p:cNvPr id="5" name="TextBox 4"/>
+          <p:cNvSpPr txBox="1"/>
+          <p:nvPr/>
+        </p:nvSpPr>
+        <p:spPr>
+          <a:xfrm>
+            <a:off x="8229600" y="1645920"/>
+            <a:ext cx="3474720" cy="4754880"/>
+          </a:xfrm>
+          <a:prstGeom prst="rect">
+            <a:avLst/>
+          </a:prstGeom>
+          <a:noFill/>
+        </p:spPr>
+        <p:txBody>
+          <a:bodyPr wrap="square" anchor="t" lIns="0" rIns="0" tIns="0" bIns="0">
+            <a:spAutoFit/>
+          </a:bodyPr>
+          <a:lstStyle/>
+          <a:p>
+            <a:pPr algn="l" marL="256032" indent="-256032">
+              <a:spcAft>
+                <a:spcPts val="1000"/>
+              </a:spcAft>
+              <a:buChar char="•"/>
+            </a:pPr>
+            <a:r>
+              <a:rPr sz="1500" b="1" i="0">
+                <a:solidFill>
+                  <a:srgbClr val="0B4F5C"/>
+                </a:solidFill>
+                <a:latin typeface="Calibri"/>
+              </a:rPr>
+              <a:t>H3 não confirmada: </a:t>
+            </a:r>
+            <a:r>
+              <a:rPr sz="1500" b="0" i="0">
+                <a:solidFill>
+                  <a:srgbClr val="1F2A2E"/>
+                </a:solidFill>
+                <a:latin typeface="Calibri"/>
+              </a:rPr>
+              <a:t>O/E na baixa escolaridade 1,06 (IC 0,97–1,16), que inclui 1.</a:t>
+            </a:r>
+          </a:p>
+          <a:p>
+            <a:pPr algn="l" marL="256032" indent="-256032">
+              <a:spcAft>
+                <a:spcPts val="1000"/>
+              </a:spcAft>
+              <a:buChar char="•"/>
+            </a:pPr>
+            <a:r>
+              <a:rPr sz="1500" b="0" i="0">
+                <a:solidFill>
+                  <a:srgbClr val="1F2A2E"/>
+                </a:solidFill>
+                <a:latin typeface="Calibri"/>
+              </a:rPr>
+              <a:t>Modelo A homogêneo: AUROC de 0,950 a 0,962.</a:t>
+            </a:r>
+          </a:p>
+          <a:p>
+            <a:pPr algn="l" marL="256032" indent="-256032">
+              <a:spcAft>
+                <a:spcPts val="1000"/>
+              </a:spcAft>
+              <a:buChar char="•"/>
+            </a:pPr>
+            <a:r>
+              <a:rPr sz="1500" b="0" i="0">
+                <a:solidFill>
+                  <a:srgbClr val="1F2A2E"/>
+                </a:solidFill>
+                <a:latin typeface="Calibri"/>
+              </a:rPr>
+              <a:t>Modelo B subestima mães brancas (O/E 1,15) e o interior (O/E 1,08).</a:t>
+            </a:r>
+          </a:p>
+          <a:p>
+            <a:pPr algn="l" marL="256032" indent="-256032">
+              <a:spcAft>
+                <a:spcPts val="1000"/>
+              </a:spcAft>
+              <a:buChar char="•"/>
+            </a:pPr>
+            <a:r>
+              <a:rPr sz="1500" b="0" i="0">
+                <a:solidFill>
+                  <a:srgbClr val="1F2A2E"/>
+                </a:solidFill>
+                <a:latin typeface="Calibri"/>
+              </a:rPr>
+              <a:t>Linkage não explica o interior: a completude cresceu igual nas duas regiões em 2023.</a:t>
+            </a:r>
+          </a:p>
+        </p:txBody>
+      </p:sp>
+    </p:spTree>
+  </p:cSld>
+  <p:clrMapOvr>
+    <a:masterClrMapping/>
+  </p:clrMapOvr>
+</p:sld>
+</file>
+
+<file path=ppt/slides/slide15.xml><?xml version="1.0" encoding="utf-8"?>
+<p:sld xmlns:a="http://schemas.openxmlformats.org/drawingml/2006/main" xmlns:p="http://schemas.openxmlformats.org/presentationml/2006/main" xmlns:r="http://schemas.openxmlformats.org/officeDocument/2006/relationships">
+  <p:cSld>
+    <p:bg>
+      <p:bgPr>
+        <a:solidFill>
+          <a:srgbClr val="FFFFFF"/>
+        </a:solidFill>
+        <a:effectLst/>
+      </p:bgPr>
+    </p:bg>
+    <p:spTree>
+      <p:nvGrpSpPr>
+        <p:cNvPr id="1" name=""/>
+        <p:cNvGrpSpPr/>
+        <p:nvPr/>
+      </p:nvGrpSpPr>
+      <p:grpSpPr/>
+      <p:sp>
+        <p:nvSpPr>
+          <p:cNvPr id="2" name="TextBox 1"/>
+          <p:cNvSpPr txBox="1"/>
+          <p:nvPr/>
+        </p:nvSpPr>
+        <p:spPr>
+          <a:xfrm>
+            <a:off x="548640" y="411480"/>
+            <a:ext cx="11094415" cy="731520"/>
+          </a:xfrm>
+          <a:prstGeom prst="rect">
+            <a:avLst/>
+          </a:prstGeom>
+          <a:noFill/>
+        </p:spPr>
+        <p:txBody>
+          <a:bodyPr wrap="square" anchor="t" lIns="0" rIns="0" tIns="0" bIns="0">
+            <a:spAutoFit/>
+          </a:bodyPr>
+          <a:lstStyle/>
+          <a:p>
+            <a:pPr algn="l">
+              <a:spcAft>
+                <a:spcPts val="600"/>
+              </a:spcAft>
+            </a:pPr>
+            <a:r>
+              <a:rPr sz="3400" b="1" i="0">
+                <a:solidFill>
+                  <a:srgbClr val="0B4F5C"/>
+                </a:solidFill>
+                <a:latin typeface="Cambria"/>
+              </a:rPr>
               <a:t>Sensibilidade ao linkage e limitações</a:t>
             </a:r>
           </a:p>
@@ -5579,7 +6138,7 @@
                 </a:solidFill>
                 <a:latin typeface="Calibri"/>
               </a:rPr>
-              <a:t>ΔAUROC -0,0001 (estrito) e -0,0005 (pior caso), com IC que incluem 0. A discriminação é robusta,</a:t>
+              <a:t>ΔAUROC -0,0001 (estrito) e -0,0005 (pior caso): robusto a ruído de rótulo no treino; o O/E sobe para 1,15–1,23.</a:t>
             </a:r>
           </a:p>
           <a:p>
@@ -5595,7 +6154,7 @@
                 </a:solidFill>
                 <a:latin typeface="Calibri"/>
               </a:rPr>
-              <a:t>mas o O/E sobe para 1,15–1,23: a calibração depende da completude do linkage.</a:t>
+              <a:t>No teste sem os pares tolerantes, AUROC 0,959: eles não inflam o resultado. Os óbitos sem par não podem ser avaliados.</a:t>
             </a:r>
           </a:p>
         </p:txBody>
@@ -5721,7 +6280,7 @@
                 </a:solidFill>
                 <a:latin typeface="Calibri"/>
               </a:rPr>
-              <a:t>≈15% dos óbitos sem par verdadeiro; menos extremos e mais do interior.</a:t>
+              <a:t>≈15% sem par verdadeiro: mais ausências, interior e óbito precoce fora do hospital.</a:t>
             </a:r>
           </a:p>
         </p:txBody>
@@ -6112,7 +6671,7 @@
 </p:sld>
 </file>
 
-<file path=ppt/slides/slide14.xml><?xml version="1.0" encoding="utf-8"?>
+<file path=ppt/slides/slide16.xml><?xml version="1.0" encoding="utf-8"?>
 <p:sld xmlns:a="http://schemas.openxmlformats.org/drawingml/2006/main" xmlns:p="http://schemas.openxmlformats.org/presentationml/2006/main" xmlns:r="http://schemas.openxmlformats.org/officeDocument/2006/relationships">
   <p:cSld>
     <p:bg>
@@ -6256,7 +6815,7 @@
                 </a:solidFill>
                 <a:latin typeface="Calibri"/>
               </a:rPr>
-              <a:t>Linkage aberto: 90,1% pareados (≈85% verdadeiros); discriminação robusta a ele.</a:t>
+              <a:t>Linkage aberto: 90,1% pareados (≈85% verdadeiros); robusto a ruído no treino.</a:t>
             </a:r>
           </a:p>
         </p:txBody>
@@ -6440,7 +6999,7 @@
                 </a:solidFill>
                 <a:latin typeface="Calibri"/>
               </a:rPr>
-              <a:t>Na admissão para o parto: AUROC 0,890 e benefício líquido positivo.</a:t>
+              <a:t>Admissão para o parto: AUROC 0,890; explicações SHAP estáveis e plausíveis.</a:t>
             </a:r>
           </a:p>
         </p:txBody>

</xml_diff>

<commit_message>
Teste no ano mais recente: treino 2017–2022, validação 2023, teste 2024
- Período parametrizado (download.ANOS_*, PRELIMINARES; preprocess.ANO_VALIDACAO/ANO_TESTE);
  SIM 2025 lido da pasta preliminar e marcado no manifesto
- Relatório, slides, notebook e apresentação do tema tiram os anos do código
- README e roteiro de arguição gerados de templates com as mesmas macros do relatório
- Texto revisto com os resultados de 2024: recalibração indispensável (peso de classe
  √(n0/n1)), XGBoost ≈ LR em AUROC, discriminação menor na baixa escolaridade,
  calibração por subgrupo instável entre anos, novos casos de XAI (erro de rótulo,
  anomalia sem tipo)

Co-Authored-By: Claude Opus 5.5 (1M context) <noreply@anthropic.com>
</commit_message>
<xml_diff>
--- a/slides/apresentacao.pptx
+++ b/slides/apresentacao.pptx
@@ -587,7 +587,7 @@
           <a:lstStyle/>
           <a:p>
             <a:r>
-              <a:t>O modelo pré-parto perde 0,066 de AUROC e bem mais de AUPRC, mas ainda chega a 0,890. H2 se confirma em parte: perdeu, mas continua útil. Pelo SHAP, quase tudo vem da idade gestacional. Por isso, o uso precisa ser bem delimitado: na admissão, com o parto iminente, para decidir transferência in utero para uma maternidade com UTI neonatal e preparar a equipe. Ele não serve para triagem precoce da gestação, porque nem a idade gestacional do parto nem as consultas acumuladas são conhecidas semanas antes. Essa é uma pergunta provável da banca.</a:t>
+              <a:t>O modelo pré-parto perde 0,074 de AUROC e bem mais de AUPRC, mas ainda chega a 0,891. H2 se confirma em parte: perdeu, mas continua útil. Pelo SHAP, quase tudo vem da idade gestacional. Por isso, o uso precisa ser bem delimitado: na admissão, com o parto iminente, para decidir transferência in utero para uma maternidade com UTI neonatal e preparar a equipe. Ele não serve para triagem precoce da gestação, porque nem a idade gestacional do parto nem as consultas acumuladas são conhecidas semanas antes. Essa é uma pergunta provável da banca.</a:t>
             </a:r>
           </a:p>
         </p:txBody>
@@ -657,7 +657,7 @@
           <a:lstStyle/>
           <a:p>
             <a:r>
-              <a:t>A pergunta mais provável é se os erros do linkage explicam os resultados. Para testar, reajustei o modelo com rótulos alternativos no treino, avaliando sempre no mesmo teste de 2023. No cenário estrito, removi os pares duvidosos. No pior caso, marquei-os como sobreviventes. A AUROC mudou -0,0001 e -0,0005, com intervalos que incluem zero: o modelo é robusto a ruído de rótulo no treino. No teste, sem os pares duvidosos, a AUROC fica em 0,959, então eles não inflam o resultado. Os óbitos que ficaram sem par, esses sim, não podem ser avaliados. Já o O/E sobe para até 1,23: a calibração absoluta depende da completude do linkage. As limitações principais são os rótulos imperfeitos, a falta de validação externa e o uso de variáveis do pós-parto no modelo A.</a:t>
+              <a:t>A pergunta mais provável é se os erros do linkage explicam os resultados. Para testar, reajustei o modelo com rótulos alternativos no treino, avaliando sempre no mesmo teste de 2024. No cenário estrito, removi os pares duvidosos. No pior caso, marquei-os como sobreviventes. A AUROC mudou -0,0009 e -0,0013, com intervalos que incluem zero: o modelo é robusto a ruído de rótulo no treino. No teste, sem os pares duvidosos, a AUROC fica em 0,965, então eles não inflam o resultado. Os óbitos que ficaram sem par, esses sim, não podem ser avaliados. Já o O/E sobe para até 1,16: a calibração absoluta depende da completude do linkage. As limitações principais são os rótulos imperfeitos, a falta de validação externa e o uso de variáveis do pós-parto no modelo A.</a:t>
             </a:r>
           </a:p>
         </p:txBody>
@@ -797,7 +797,7 @@
           <a:lstStyle/>
           <a:p>
             <a:r>
-              <a:t>Agora a explicabilidade. Usei SHAP, que decompõe o log-odds de cada nascimento em contribuições aditivas. Primeiro verifiquei a aditividade: a soma reproduz a predição com erro menor que 1e-5. Isso expôs uma armadilha: com early stopping, o XGBoost usa por padrão todas as árvores, inclusive as posteriores à melhor iteração, e o SHAP explicaria outro modelo. Nos gráficos de dependência, os efeitos são clinicamente plausíveis: o risco cai com Apgar, peso e idade gestacional, e sobe com a idade materna acima de 38 anos. As consultas de pré-natal têm forma de U: acima de 14 consultas, o risco sobe. Isso é confusão por indicação, porque gestações de alto risco são mais acompanhadas. Então o SHAP mostra associação no modelo, não causa.</a:t>
+              <a:t>Agora a explicabilidade. Usei SHAP, que decompõe o log-odds de cada nascimento em contribuições aditivas. Primeiro verifiquei a aditividade: a soma reproduz a predição com erro menor que 1e-5. Isso expôs uma armadilha: com early stopping, o XGBoost usa por padrão todas as árvores, inclusive as posteriores à melhor iteração, e o SHAP explicaria outro modelo. Nos gráficos de dependência, os efeitos são clinicamente plausíveis: o risco cai com Apgar, peso e idade gestacional, e sobe com a idade materna acima de 37 anos. As consultas de pré-natal têm forma de U: acima de 17 consultas, o risco sobe. Isso é confusão por indicação, porque gestações de alto risco são mais acompanhadas. Então o SHAP mostra associação no modelo, não causa.</a:t>
             </a:r>
           </a:p>
         </p:txBody>
@@ -867,7 +867,7 @@
           <a:lstStyle/>
           <a:p>
             <a:r>
-              <a:t>As explicações locais mostram três casos. O óbito bem previsto tinha 374 gramas e Apgar zero. O óbito que o modelo não sinalizou tinha Apgar 5 e 7 e 2,2 quilos: um recém-nascido de risco moderado, que a DN não distingue de sobreviventes parecidos. O falso positivo tinha Apgar 1 e 1 e anomalia, e sobreviveu. Ou seja, os erros vêm de falta de informação na DN, não de efeitos espúrios. As explicações são estáveis: o ranking do XGBoost e do LightGBM tem correlação de 0,96, e entre metades da amostra, 0,999. No modelo pré-parto, raça e escolaridade pesam cerca de 8%: o modelo usa o gradiente socioeconômico no lugar do estado do recém-nascido, o que ajuda a entender a subestimação para mães brancas.</a:t>
+              <a:t>As explicações locais mostram três casos. O óbito bem previsto tinha 670 gramas, Apgar 1 e anomalia. O óbito que o modelo não sinalizou era um bebê a termo, de 3.450 gramas, com anomalia congênita: o indicador da DN é só sim ou não, e não separa malformações letais; o tipo de anomalia existe na DN e fica como trabalho futuro. O caso mais interessante é o falso positivo: 385 gramas e 21 semanas, marcado como sobrevivente. Isso é quase certamente um óbito que o linkage não pareou. A explicação expõe o ruído de rótulo. As explicações são estáveis: o ranking do XGBoost e do LightGBM tem correlação de 0,90 no modelo A, e entre metades da amostra, 0,999. No pré-parto, raça e escolaridade pesam 8% da importância.</a:t>
             </a:r>
           </a:p>
         </p:txBody>
@@ -937,7 +937,7 @@
           <a:lstStyle/>
           <a:p>
             <a:r>
-              <a:t>A curva de calibração acompanha a diagonal, e as inclinações são próximas de 1. Um achado honesto: a recalibração isotônica, ajustada em 2022, piorou um pouco o O/E no teste, de 0,99 para 1,02 no modelo A. A explicação plausível é o drift: a mortalidade subiu em 2023, e parte disso vem da completude do linkage, que também subiu. Na curva de decisão, tratar todos é negativo para qualquer limiar acima da prevalência, então superá-lo é trivial; a comparação que importa é com não intervir. Escolhi a faixa de 2 a 10% pelo uso clínico: para uma transferência in utero, é razoável aceitar entre 9 e 49 falsos alarmes por óbito identificado. Nessa faixa, o benefício líquido é sempre positivo nos dois modelos.</a:t>
+              <a:t>A busca escolheu reponderar a classe positiva, e por isso o escore bruto superestima o risco: O/E de 0,23, as curvas pontilhadas. A recalibração isotônica, ajustada em 2023, é indispensável e leva o O/E a 0,95; a curva recalibrada acompanha a diagonal. A leve superestimação que sobra é compatível com a queda da mortalidade de 2023 para 2024. Na curva de decisão, tratar todos é negativo para qualquer limiar acima da prevalência, então superá-lo é trivial; a comparação que importa é com não intervir. Escolhi a faixa de 2 a 10% pelo uso clínico: para uma transferência in utero, é razoável aceitar entre 9 e 49 falsos alarmes por óbito identificado. Nessa faixa, o benefício líquido é sempre positivo nos dois modelos.</a:t>
             </a:r>
           </a:p>
         </p:txBody>
@@ -1007,7 +1007,7 @@
           <a:lstStyle/>
           <a:p>
             <a:r>
-              <a:t>Subgrupos e H3. A hipótese era calibração pior na baixa escolaridade. O O/E nesse grupo foi 1,06, com intervalo que inclui 1, então H3 não se confirmou. O modelo completo é homogêneo. O pré-parto subestima o risco para mães brancas e para o interior. Testei se o linkage explica o interior: a completude é estável ao longo dos anos e subiu igualmente nas duas regiões em 2023. Então não explica, e restam fatores regionais. Para mães brancas, o pareamento é quase igual por raça, mas essa evidência é indireta, porque a DO informa a raça do recém-nascido, e não a da mãe.</a:t>
+              <a:t>Subgrupos e H3. A hipótese era calibração pior na baixa escolaridade. O O/E nesse grupo foi 0,99, com intervalo que inclui 1, então H3 não se confirmou. O achado de equidade que se sustenta é outro: no modelo completo, a discriminação é pior para filhos de mães com baixa escolaridade, com AUROC de 0,950 contra 0,980, e os intervalos não se sobrepõem. Já as diferenças de calibração por subgrupo mudaram de um ano para outro: no teste de 2023, o modelo subestimava mães brancas e o interior, e em 2024 isso não se repetiu. Por isso não as interpreto como viés estrutural. Testei também o linkage diferencial por região: ele desloca o O/E em menos de 2% e não explica as diferenças.</a:t>
             </a:r>
           </a:p>
         </p:txBody>
@@ -1077,7 +1077,7 @@
           <a:lstStyle/>
           <a:p>
             <a:r>
-              <a:t>Óbito neonatal é o que ocorre de 0 a 27 dias de vida. É a maior parte da mortalidade infantil. No RJ, entre 2017 e 2023, foram 8,6 óbitos por mil nascidos vivos, 12.039 ao todo. Boa parte é evitável, e o risco se concentra em poucos nascimentos. A Declaração de Nascido Vivo é preenchida para todo nascimento, em qualquer município. Um escore calculado a partir dela pode ajudar a priorizar UTI neonatal, transporte e visita domiciliar. A pergunta é se isso é possível com os dados que qualquer pesquisador pode baixar.</a:t>
+              <a:t>Óbito neonatal é o que ocorre de 0 a 27 dias de vida. É a maior parte da mortalidade infantil. No RJ, entre 2017 e 2024, foram 8,6 óbitos por mil nascidos vivos, 13.471 ao todo. Boa parte é evitável, e o risco se concentra em poucos nascimentos. A Declaração de Nascido Vivo é preenchida para todo nascimento, em qualquer município. Um escore calculado a partir dela pode ajudar a priorizar UTI neonatal, transporte e visita domiciliar. A pergunta é se isso é possível com os dados que qualquer pesquisador pode baixar.</a:t>
             </a:r>
           </a:p>
         </p:txBody>
@@ -1287,7 +1287,7 @@
           <a:lstStyle/>
           <a:p>
             <a:r>
-              <a:t>Os dados são o SINASC e o SIM do DATASUS, por residência no RJ, baixados do FTP público, sem cadastro. São 1.397.216 nascidos vivos. O SIM vai até 2024 para captar quem nasceu em dezembro de 2023. O desenho é temporal, como no artigo: ajuste em 2017 a 2021, validação em 2022 e teste em 2023, usado uma única vez. Um detalhe importante: a TMN do teste, 8,20, é maior que a do treino, 7,70. Isso vai aparecer na calibração. Registrei o hash SHA-256 de cada arquivo, porque o DATASUS revisa os dados.</a:t>
+              <a:t>Os dados são o SINASC e o SIM do DATASUS, por residência no RJ, baixados do FTP público, sem cadastro. São 1.560.938 nascidos vivos. O SIM vai até 2025 para captar quem nasceu em dezembro de 2024. O desenho é temporal, como no artigo: ajuste em 2017 a 2022, validação em 2023 e teste em 2024, usado uma única vez. Um detalhe importante: a TMN oscila entre os anos: 8,20 na validação e 7,98 no teste. Isso vai aparecer na calibração. Registrei o hash SHA-256 de cada arquivo, porque o DATASUS revisa os dados.</a:t>
             </a:r>
           </a:p>
         </p:txBody>
@@ -1357,7 +1357,7 @@
           <a:lstStyle/>
           <a:p>
             <a:r>
-              <a:t>Esta é a parte central. Os arquivos públicos não têm o número da DN nem nomes. Mas a Declaração de Óbito de menores de um ano repete dados do nascimento. Então pareio por chaves compostas, em cascata, aceitando só pares únicos. Pareei 90,1% dos óbitos. Parte desses pares é falsa: estimei isso comparando campos que não entram nas chaves, e o resultado é cerca de 85% dos óbitos com par verdadeiro. A estimativa supõe que a primeira passada, com oito campos, não tem falsos pares. O pareamento é 94,3% na capital e 88,0% no interior. Os não pareados são os óbitos sem peso, semanas ou idade da mãe na DO: 27% deles não têm peso.</a:t>
+              <a:t>Esta é a parte central. Os arquivos públicos não têm o número da DN nem nomes. Mas a Declaração de Óbito de menores de um ano repete dados do nascimento. Então pareio por chaves compostas, em cascata, aceitando só pares únicos. Pareei 90,2% dos óbitos. Parte desses pares é falsa: estimei isso comparando campos que não entram nas chaves, e o resultado é cerca de 85% dos óbitos com par verdadeiro. A estimativa supõe que a primeira passada, com oito campos, não tem falsos pares. O pareamento é 94,3% na capital e 88,2% no interior. Os não pareados são os óbitos sem peso, semanas ou idade da mãe na DO: 27% deles não têm peso.</a:t>
             </a:r>
           </a:p>
         </p:txBody>
@@ -1497,7 +1497,7 @@
           <a:lstStyle/>
           <a:p>
             <a:r>
-              <a:t>No teste de 2023, o XGBoost completo teve AUROC de 0,956 e AUPRC de 0,576. O artigo teve 0,971 e 0,586. H1 se confirma. A logística fica muito perto: o ganho do XGBoost em AUROC é de 0,003, com limite inferior praticamente zero, e o ganho mais claro está na AUPRC. Na prática, as variáveis da DN carregam quase toda a informação, e o algoritmo importa pouco. A precisão no limiar é maior e a sensibilidade menor que no artigo, mas isso decorre da escolha do limiar.</a:t>
+              <a:t>No teste de 2024, o XGBoost completo teve AUROC de 0,964 e AUPRC de 0,603. O artigo teve 0,971 e 0,586. H1 se confirma. A logística fica muito perto: em AUROC, a diferença para o XGBoost é de 0,001, com intervalo que inclui zero. O ganho do XGBoost aparece na AUPRC, entre os casos de maior risco. Na prática, as variáveis da DN carregam quase toda a informação, e o algoritmo importa pouco. A precisão no limiar é maior e a sensibilidade menor que no artigo, mas isso decorre da escolha do limiar.</a:t>
             </a:r>
           </a:p>
         </p:txBody>
@@ -1567,7 +1567,7 @@
           <a:lstStyle/>
           <a:p>
             <a:r>
-              <a:t>Nas curvas, as linhas cheias são o modelo completo e as tracejadas, o pré-parto. Os três algoritmos quase se sobrepõem. À direita está a métrica operacional: priorizando 5% dos nascimentos, o modelo completo captura 87% dos óbitos e o pré-parto, 72%. Ramos e colegas, em 2025, com dados nacionais, encontraram mais de 85%, o que é coerente. A diferença para os 90% do artigo é compatível com os óbitos sem par verdadeiro, que têm outro perfil (mais campos ausentes, mais do interior, mais óbitos precoces fora do hospital), e com a heterogeneidade do estado.</a:t>
+              <a:t>Nas curvas, as linhas cheias são o modelo completo e as tracejadas, o pré-parto. Os três algoritmos quase se sobrepõem. À direita está a métrica operacional: priorizando 5% dos nascimentos, o modelo completo captura 88% dos óbitos e o pré-parto, 71%. Ramos e colegas, em 2025, com dados nacionais, encontraram mais de 85%, o que é coerente. A diferença para os 90% do artigo é compatível com os óbitos sem par verdadeiro, que têm outro perfil (mais campos ausentes, mais do interior, mais óbitos precoces fora do hospital), e com a heterogeneidade do estado.</a:t>
             </a:r>
           </a:p>
         </p:txBody>
@@ -4654,7 +4654,7 @@
                 </a:solidFill>
                 <a:latin typeface="Calibri"/>
               </a:rPr>
-              <a:t>Linkage SINASC × SIM sem identificadores e aprendizado de máquina · 1.397.216 nascidos vivos, 2017–2023</a:t>
+              <a:t>Linkage SINASC × SIM sem identificadores e aprendizado de máquina · 1.560.938 nascidos vivos, 2017–2024</a:t>
             </a:r>
           </a:p>
         </p:txBody>
@@ -4898,7 +4898,7 @@
                 </a:solidFill>
                 <a:latin typeface="Cambria"/>
               </a:rPr>
-              <a:t>0,890</a:t>
+              <a:t>0,891</a:t>
             </a:r>
           </a:p>
         </p:txBody>
@@ -5022,7 +5022,7 @@
                 </a:solidFill>
                 <a:latin typeface="Cambria"/>
               </a:rPr>
-              <a:t>−0,066</a:t>
+              <a:t>−0,074</a:t>
             </a:r>
           </a:p>
         </p:txBody>
@@ -5061,7 +5061,7 @@
                 </a:solidFill>
                 <a:latin typeface="Calibri"/>
               </a:rPr>
-              <a:t>ΔAUROC (IC 0,056–0,076); ΔAUPRC −0,169</a:t>
+              <a:t>ΔAUROC (IC 0,064–0,084); ΔAUPRC −0,214</a:t>
             </a:r>
           </a:p>
         </p:txBody>
@@ -5083,7 +5083,7 @@
         <p:spPr>
           <a:xfrm>
             <a:off x="4114800" y="1737360"/>
-            <a:ext cx="7589520" cy="3124200"/>
+            <a:ext cx="7589520" cy="3128912"/>
           </a:xfrm>
           <a:prstGeom prst="rect">
             <a:avLst/>
@@ -5253,7 +5253,7 @@
                 </a:solidFill>
                 <a:latin typeface="Calibri"/>
               </a:rPr>
-              <a:t>SHAP exato (TreeSHAP) em 20 mil nascimentos de 2023</a:t>
+              <a:t>SHAP exato (TreeSHAP) em 20 mil nascimentos de 2024</a:t>
             </a:r>
           </a:p>
         </p:txBody>
@@ -5275,7 +5275,7 @@
         <p:spPr>
           <a:xfrm>
             <a:off x="548640" y="1600200"/>
-            <a:ext cx="7406640" cy="3739011"/>
+            <a:ext cx="7406640" cy="3742446"/>
           </a:xfrm>
           <a:prstGeom prst="rect">
             <a:avLst/>
@@ -5360,7 +5360,7 @@
                 </a:solidFill>
                 <a:latin typeface="Calibri"/>
               </a:rPr>
-              <a:t>Idade da mãe &gt; 38 anos aumenta o risco (modelo B).</a:t>
+              <a:t>Idade da mãe &gt; 37 anos aumenta o risco (modelo B).</a:t>
             </a:r>
           </a:p>
           <a:p>
@@ -5386,7 +5386,7 @@
                 </a:solidFill>
                 <a:latin typeface="Calibri"/>
               </a:rPr>
-              <a:t>mais de 14 consultas aumenta o risco, confusão por indicação. SHAP é associação, não causa.</a:t>
+              <a:t>mais de 17 consultas aumenta o risco, confusão por indicação. SHAP é associação, não causa.</a:t>
             </a:r>
           </a:p>
         </p:txBody>
@@ -5473,7 +5473,7 @@
         <p:spPr>
           <a:xfrm>
             <a:off x="548640" y="1188720"/>
-            <a:ext cx="11094415" cy="3034960"/>
+            <a:ext cx="11094415" cy="3014936"/>
           </a:xfrm>
           <a:prstGeom prst="rect">
             <a:avLst/>
@@ -5515,7 +5515,7 @@
                 </a:solidFill>
                 <a:latin typeface="Calibri"/>
               </a:rPr>
-              <a:t>Os erros ocorrem onde a DN tem pouca informação: o óbito não sinalizado tinha Apgar 5/7 e 2.232 g; o falso positivo, Apgar 1/1 com anomalia, sobreviveu.</a:t>
+              <a:t>Óbito não sinalizado (4,4%): a termo, 3.450 g, com anomalia; a DN não diz o tipo de anomalia. "Sobrevivente" de 385 g e 21 semanas: quase certamente um óbito não pareado.</a:t>
             </a:r>
           </a:p>
           <a:p>
@@ -5532,7 +5532,7 @@
                 </a:solidFill>
                 <a:latin typeface="Calibri"/>
               </a:rPr>
-              <a:t>Ranking estável: Spearman XGBoost × LightGBM de 0,96 (A) e 0,89 (B); entre metades da amostra, 0,999.</a:t>
+              <a:t>Ranking estável: Spearman XGBoost × LightGBM de 0,90 (A) e 0,98 (B); entre metades da amostra, 0,999.</a:t>
             </a:r>
           </a:p>
           <a:p>
@@ -5549,7 +5549,7 @@
                 </a:solidFill>
                 <a:latin typeface="Calibri"/>
               </a:rPr>
-              <a:t>Raça/cor e escolaridade da mãe respondem por 8,1% da importância no modelo B: é o gradiente socioeconômico substituindo o estado do recém-nascido.</a:t>
+              <a:t>Raça/cor e escolaridade da mãe respondem por 7,9% da importância no modelo B: é o gradiente socioeconômico substituindo o estado do recém-nascido.</a:t>
             </a:r>
           </a:p>
         </p:txBody>
@@ -5653,7 +5653,7 @@
                 </a:solidFill>
                 <a:latin typeface="Calibri"/>
               </a:rPr>
-              <a:t>XGBoost, teste de 2023</a:t>
+              <a:t>XGBoost, teste de 2024</a:t>
             </a:r>
           </a:p>
         </p:txBody>
@@ -5717,7 +5717,7 @@
                 </a:solidFill>
                 <a:latin typeface="Calibri"/>
               </a:rPr>
-              <a:t>Curva próxima da diagonal; inclinação 0,98 (A) e 0,99 (B). A isotônica piorou um pouco o O/E no teste (0,99 → 1,02 em A): drift de 2022 para 2023 é a explicação plausível.</a:t>
+              <a:t>Curva próxima da diagonal; inclinação 1,01 (A) e 0,98 (B). Recalibrar é indispensável: com o peso de classe escolhido, o escore bruto tem O/E 0,23; a isotônica leva a 0,95. A leve superestimação acompanha a queda da TMN de 8,20‰ (2023) para 7,98‰ (2024).</a:t>
             </a:r>
           </a:p>
           <a:p>
@@ -5751,7 +5751,7 @@
                 </a:solidFill>
                 <a:latin typeface="Calibri"/>
               </a:rPr>
-              <a:t>Faixa clínica 2–10% (9 a 49 falsos alarmes por óbito): benefício de 6,2–4,9 por mil (A) e 5,0–3,6 (B).</a:t>
+              <a:t>Faixa clínica 2–10% (9 a 49 falsos alarmes por óbito): benefício de 6,2–4,9 por mil (A) e 4,7–3,3 (B).</a:t>
             </a:r>
           </a:p>
         </p:txBody>
@@ -5928,7 +5928,7 @@
                 </a:solidFill>
                 <a:latin typeface="Calibri"/>
               </a:rPr>
-              <a:t>O/E na baixa escolaridade 1,06 (IC 0,97–1,16), que inclui 1.</a:t>
+              <a:t>O/E na baixa escolaridade 0,99 (IC 0,90–1,09), que inclui 1.</a:t>
             </a:r>
           </a:p>
           <a:p>
@@ -5939,13 +5939,22 @@
               <a:buChar char="•"/>
             </a:pPr>
             <a:r>
+              <a:rPr sz="1500" b="1" i="0">
+                <a:solidFill>
+                  <a:srgbClr val="0B4F5C"/>
+                </a:solidFill>
+                <a:latin typeface="Calibri"/>
+              </a:rPr>
+              <a:t>Discriminação: </a:t>
+            </a:r>
+            <a:r>
               <a:rPr sz="1500" b="0" i="0">
                 <a:solidFill>
                   <a:srgbClr val="1F2A2E"/>
                 </a:solidFill>
                 <a:latin typeface="Calibri"/>
               </a:rPr>
-              <a:t>Modelo A homogêneo: AUROC de 0,950 a 0,962.</a:t>
+              <a:t>no modelo A, AUROC de 0,950 na baixa escolaridade contra 0,980 no superior (IC não se sobrepõem).</a:t>
             </a:r>
           </a:p>
           <a:p>
@@ -5962,24 +5971,7 @@
                 </a:solidFill>
                 <a:latin typeface="Calibri"/>
               </a:rPr>
-              <a:t>Modelo B subestima mães brancas (O/E 1,15) e o interior (O/E 1,08).</a:t>
-            </a:r>
-          </a:p>
-          <a:p>
-            <a:pPr algn="l" marL="256032" indent="-256032">
-              <a:spcAft>
-                <a:spcPts val="1000"/>
-              </a:spcAft>
-              <a:buChar char="•"/>
-            </a:pPr>
-            <a:r>
-              <a:rPr sz="1500" b="0" i="0">
-                <a:solidFill>
-                  <a:srgbClr val="1F2A2E"/>
-                </a:solidFill>
-                <a:latin typeface="Calibri"/>
-              </a:rPr>
-              <a:t>Linkage não explica o interior: a completude cresceu igual nas duas regiões em 2023.</a:t>
+              <a:t>Calibração por subgrupo instável: os desvios vistos no teste de 2023 não se repetiram em 2024.</a:t>
             </a:r>
           </a:p>
         </p:txBody>
@@ -6129,7 +6121,7 @@
                 </a:solidFill>
                 <a:latin typeface="Calibri"/>
               </a:rPr>
-              <a:t>Mesmo teste de 2023, rótulos alternativos no treino: </a:t>
+              <a:t>Mesmo teste de 2024, rótulos alternativos no treino: </a:t>
             </a:r>
             <a:r>
               <a:rPr sz="1500" b="0" i="0">
@@ -6138,7 +6130,7 @@
                 </a:solidFill>
                 <a:latin typeface="Calibri"/>
               </a:rPr>
-              <a:t>ΔAUROC -0,0001 (estrito) e -0,0005 (pior caso): robusto a ruído de rótulo no treino; o O/E sobe para 1,15–1,23.</a:t>
+              <a:t>ΔAUROC -0,0009 (estrito) e -0,0013 (pior caso): robusto a ruído de rótulo no treino; o O/E sobe para 1,07–1,16.</a:t>
             </a:r>
           </a:p>
           <a:p>
@@ -6154,7 +6146,7 @@
                 </a:solidFill>
                 <a:latin typeface="Calibri"/>
               </a:rPr>
-              <a:t>No teste sem os pares tolerantes, AUROC 0,959: eles não inflam o resultado. Os óbitos sem par não podem ser avaliados.</a:t>
+              <a:t>No teste sem os pares tolerantes, AUROC 0,965: eles não inflam o resultado. Os óbitos sem par não podem ser avaliados.</a:t>
             </a:r>
           </a:p>
         </p:txBody>
@@ -6658,7 +6650,7 @@
                 </a:solidFill>
                 <a:latin typeface="Calibri"/>
               </a:rPr>
-              <a:t>Precisão de 63% no limiar (A): alertas precisam de desenho de fluxo.</a:t>
+              <a:t>Precisão de 60% no limiar (A): alertas precisam de desenho de fluxo.</a:t>
             </a:r>
           </a:p>
         </p:txBody>
@@ -6815,7 +6807,7 @@
                 </a:solidFill>
                 <a:latin typeface="Calibri"/>
               </a:rPr>
-              <a:t>Linkage aberto: 90,1% pareados (≈85% verdadeiros); robusto a ruído no treino.</a:t>
+              <a:t>Linkage aberto: 90,2% pareados (≈85% verdadeiros); robusto a ruído no treino.</a:t>
             </a:r>
           </a:p>
         </p:txBody>
@@ -6907,7 +6899,7 @@
                 </a:solidFill>
                 <a:latin typeface="Calibri"/>
               </a:rPr>
-              <a:t>Reprodução do artigo no RJ: AUROC 0,956 e 87% dos óbitos no top 5%.</a:t>
+              <a:t>Reprodução do artigo no RJ: AUROC 0,964 e 88% dos óbitos no top 5%.</a:t>
             </a:r>
           </a:p>
         </p:txBody>
@@ -6999,7 +6991,7 @@
                 </a:solidFill>
                 <a:latin typeface="Calibri"/>
               </a:rPr>
-              <a:t>Admissão para o parto: AUROC 0,890; explicações SHAP estáveis e plausíveis.</a:t>
+              <a:t>Admissão para o parto: AUROC 0,891; explicações SHAP estáveis e plausíveis.</a:t>
             </a:r>
           </a:p>
         </p:txBody>
@@ -7351,7 +7343,7 @@
                 </a:solidFill>
                 <a:latin typeface="Calibri"/>
               </a:rPr>
-              <a:t>óbitos neonatais por mil nascidos vivos no RJ, 2017–2023 (SIM)</a:t>
+              <a:t>óbitos neonatais por mil nascidos vivos no RJ, 2017–2024 (SIM)</a:t>
             </a:r>
           </a:p>
         </p:txBody>
@@ -7436,7 +7428,7 @@
                 </a:solidFill>
                 <a:latin typeface="Cambria"/>
               </a:rPr>
-              <a:t>12.039</a:t>
+              <a:t>13.471</a:t>
             </a:r>
           </a:p>
         </p:txBody>
@@ -9069,7 +9061,7 @@
                 </a:solidFill>
                 <a:latin typeface="Calibri"/>
               </a:rPr>
-              <a:t>Ajuste · 2017–2021</a:t>
+              <a:t>Ajuste · 2017–2022</a:t>
             </a:r>
           </a:p>
         </p:txBody>
@@ -9108,7 +9100,7 @@
                 </a:solidFill>
                 <a:latin typeface="Cambria"/>
               </a:rPr>
-              <a:t>1.040.702</a:t>
+              <a:t>1.221.071</a:t>
             </a:r>
           </a:p>
         </p:txBody>
@@ -9147,7 +9139,7 @@
                 </a:solidFill>
                 <a:latin typeface="Calibri"/>
               </a:rPr>
-              <a:t>nascidos vivos · 8.017 óbitos</a:t>
+              <a:t>nascidos vivos · 9.405 óbitos</a:t>
             </a:r>
           </a:p>
         </p:txBody>
@@ -9276,7 +9268,7 @@
                 </a:solidFill>
                 <a:latin typeface="Calibri"/>
               </a:rPr>
-              <a:t>Validação · 2022</a:t>
+              <a:t>Validação · 2023</a:t>
             </a:r>
           </a:p>
         </p:txBody>
@@ -9315,7 +9307,7 @@
                 </a:solidFill>
                 <a:latin typeface="Cambria"/>
               </a:rPr>
-              <a:t>180.369</a:t>
+              <a:t>176.145</a:t>
             </a:r>
           </a:p>
         </p:txBody>
@@ -9354,7 +9346,7 @@
                 </a:solidFill>
                 <a:latin typeface="Calibri"/>
               </a:rPr>
-              <a:t>nascidos vivos · 1.388 óbitos</a:t>
+              <a:t>nascidos vivos · 1.444 óbitos</a:t>
             </a:r>
           </a:p>
         </p:txBody>
@@ -9483,7 +9475,7 @@
                 </a:solidFill>
                 <a:latin typeface="Calibri"/>
               </a:rPr>
-              <a:t>Teste · 2023</a:t>
+              <a:t>Teste · 2024</a:t>
             </a:r>
           </a:p>
         </p:txBody>
@@ -9522,7 +9514,7 @@
                 </a:solidFill>
                 <a:latin typeface="Cambria"/>
               </a:rPr>
-              <a:t>176.145</a:t>
+              <a:t>163.722</a:t>
             </a:r>
           </a:p>
         </p:txBody>
@@ -9561,7 +9553,7 @@
                 </a:solidFill>
                 <a:latin typeface="Calibri"/>
               </a:rPr>
-              <a:t>nascidos vivos · 1.444 óbitos</a:t>
+              <a:t>nascidos vivos · 1.306 óbitos</a:t>
             </a:r>
           </a:p>
         </p:txBody>
@@ -9601,7 +9593,7 @@
                 </a:solidFill>
                 <a:latin typeface="Calibri"/>
               </a:rPr>
-              <a:t>SINASC (DNRJ2017–2023) e SIM (DORJ2017–2024) baixados do FTP do DATASUS, sem cadastro.</a:t>
+              <a:t>SINASC (DNRJ2017–2024) e SIM (DORJ2017–2025) baixados do FTP do DATASUS, sem cadastro.</a:t>
             </a:r>
           </a:p>
           <a:p>
@@ -9618,7 +9610,7 @@
                 </a:solidFill>
                 <a:latin typeface="Calibri"/>
               </a:rPr>
-              <a:t>Desfecho: óbito não fetal com 0 a 27 dias de vida. O SIM vai até 2024 para captar quem nasceu em dezembro de 2023.</a:t>
+              <a:t>Desfecho: óbito não fetal com 0 a 27 dias de vida. O SIM vai até 2025 para captar quem nasceu em dezembro de 2024.</a:t>
             </a:r>
           </a:p>
           <a:p>
@@ -9635,7 +9627,7 @@
                 </a:solidFill>
                 <a:latin typeface="Calibri"/>
               </a:rPr>
-              <a:t>Validação usada para hiperparâmetros, early stopping, recalibração e limiar; 2023 é avaliado uma única vez.</a:t>
+              <a:t>Validação usada para hiperparâmetros, early stopping, recalibração e limiar; 2024 é avaliado uma única vez.</a:t>
             </a:r>
           </a:p>
         </p:txBody>
@@ -9898,7 +9890,7 @@
                 </a:solidFill>
                 <a:latin typeface="Cambria"/>
               </a:rPr>
-              <a:t>90,1%</a:t>
+              <a:t>90,2%</a:t>
             </a:r>
           </a:p>
         </p:txBody>
@@ -9937,7 +9929,7 @@
                 </a:solidFill>
                 <a:latin typeface="Calibri"/>
               </a:rPr>
-              <a:t>dos 12.039 óbitos pareados</a:t>
+              <a:t>dos 13.471 óbitos pareados</a:t>
             </a:r>
           </a:p>
         </p:txBody>
@@ -10124,7 +10116,7 @@
                 </a:solidFill>
                 <a:latin typeface="Calibri"/>
               </a:rPr>
-              <a:t>Falsos pares estimados nas passadas 1–2 (que somam 82% dos pares): até 8%. As passadas tolerantes chegam a 32%. Pareamento: 94,3% na capital, 88,0% no interior. Óbitos sem peso na DO quase não pareiam.</a:t>
+              <a:t>Falsos pares estimados nas passadas 1–2 (que somam 82% dos pares): até 8%. As passadas tolerantes chegam a 31%. Pareamento: 94,3% na capital, 88,2% no interior. Óbitos sem peso na DO quase não pareiam.</a:t>
             </a:r>
           </a:p>
         </p:txBody>
@@ -10533,7 +10525,7 @@
                 </a:solidFill>
                 <a:latin typeface="Calibri"/>
               </a:rPr>
-              <a:t>Optuna/TPE maximizando a AUPRC em 2022; peso de classe como hiperparâmetro (nenhum, raiz, total).</a:t>
+              <a:t>Optuna/TPE maximizando a AUPRC em 2023; peso de classe como hiperparâmetro (nenhum, raiz, total).</a:t>
             </a:r>
           </a:p>
           <a:p>
@@ -10550,7 +10542,7 @@
                 </a:solidFill>
                 <a:latin typeface="Calibri"/>
               </a:rPr>
-              <a:t>Recalibração isotônica em 2022. Discriminação pelo escore bruto; calibração e limiar pela probabilidade.</a:t>
+              <a:t>Recalibração isotônica em 2023. Discriminação pelo escore bruto; calibração e limiar pela probabilidade.</a:t>
             </a:r>
           </a:p>
           <a:p>
@@ -10632,7 +10624,7 @@
                 </a:solidFill>
                 <a:latin typeface="Cambria"/>
               </a:rPr>
-              <a:t>Resultados no teste de 2023</a:t>
+              <a:t>Resultados no teste de 2024</a:t>
             </a:r>
           </a:p>
         </p:txBody>
@@ -10671,7 +10663,7 @@
                 </a:solidFill>
                 <a:latin typeface="Calibri"/>
               </a:rPr>
-              <a:t>IC 95% por bootstrap; limiar escolhido em 2022</a:t>
+              <a:t>IC 95% por bootstrap; limiar escolhido em 2023</a:t>
             </a:r>
           </a:p>
         </p:txBody>
@@ -10902,7 +10894,7 @@
                           </a:solidFill>
                           <a:latin typeface="Calibri"/>
                         </a:rPr>
-                        <a:t>0,953 (0,946–0,961)</a:t>
+                        <a:t>0,963 (0,956–0,969)</a:t>
                       </a:r>
                     </a:p>
                   </a:txBody>
@@ -10925,7 +10917,7 @@
                           </a:solidFill>
                           <a:latin typeface="Calibri"/>
                         </a:rPr>
-                        <a:t>0,533 (0,509–0,563)</a:t>
+                        <a:t>0,551 (0,526–0,579)</a:t>
                       </a:r>
                     </a:p>
                   </a:txBody>
@@ -10948,7 +10940,7 @@
                           </a:solidFill>
                           <a:latin typeface="Calibri"/>
                         </a:rPr>
-                        <a:t>0,546</a:t>
+                        <a:t>0,554</a:t>
                       </a:r>
                     </a:p>
                   </a:txBody>
@@ -10971,7 +10963,7 @@
                           </a:solidFill>
                           <a:latin typeface="Calibri"/>
                         </a:rPr>
-                        <a:t>86,2%</a:t>
+                        <a:t>88,0%</a:t>
                       </a:r>
                     </a:p>
                   </a:txBody>
@@ -11042,7 +11034,7 @@
                           </a:solidFill>
                           <a:latin typeface="Calibri"/>
                         </a:rPr>
-                        <a:t>0,956 (0,948–0,962)</a:t>
+                        <a:t>0,964 (0,958–0,970)</a:t>
                       </a:r>
                     </a:p>
                   </a:txBody>
@@ -11065,7 +11057,7 @@
                           </a:solidFill>
                           <a:latin typeface="Calibri"/>
                         </a:rPr>
-                        <a:t>0,576 (0,553–0,605)</a:t>
+                        <a:t>0,603 (0,577–0,628)</a:t>
                       </a:r>
                     </a:p>
                   </a:txBody>
@@ -11088,7 +11080,7 @@
                           </a:solidFill>
                           <a:latin typeface="Calibri"/>
                         </a:rPr>
-                        <a:t>0,595</a:t>
+                        <a:t>0,604</a:t>
                       </a:r>
                     </a:p>
                   </a:txBody>
@@ -11111,7 +11103,7 @@
                           </a:solidFill>
                           <a:latin typeface="Calibri"/>
                         </a:rPr>
-                        <a:t>86,8%</a:t>
+                        <a:t>88,0%</a:t>
                       </a:r>
                     </a:p>
                   </a:txBody>
@@ -11182,7 +11174,7 @@
                           </a:solidFill>
                           <a:latin typeface="Calibri"/>
                         </a:rPr>
-                        <a:t>0,956 (0,949–0,963)</a:t>
+                        <a:t>0,964 (0,958–0,970)</a:t>
                       </a:r>
                     </a:p>
                   </a:txBody>
@@ -11205,7 +11197,7 @@
                           </a:solidFill>
                           <a:latin typeface="Calibri"/>
                         </a:rPr>
-                        <a:t>0,573 (0,551–0,600)</a:t>
+                        <a:t>0,580 (0,552–0,608)</a:t>
                       </a:r>
                     </a:p>
                   </a:txBody>
@@ -11228,7 +11220,7 @@
                           </a:solidFill>
                           <a:latin typeface="Calibri"/>
                         </a:rPr>
-                        <a:t>0,580</a:t>
+                        <a:t>0,596</a:t>
                       </a:r>
                     </a:p>
                   </a:txBody>
@@ -11251,7 +11243,7 @@
                           </a:solidFill>
                           <a:latin typeface="Calibri"/>
                         </a:rPr>
-                        <a:t>86,6%</a:t>
+                        <a:t>87,7%</a:t>
                       </a:r>
                     </a:p>
                   </a:txBody>
@@ -11322,7 +11314,7 @@
                           </a:solidFill>
                           <a:latin typeface="Calibri"/>
                         </a:rPr>
-                        <a:t>0,887 (0,875–0,898)</a:t>
+                        <a:t>0,886 (0,874–0,896)</a:t>
                       </a:r>
                     </a:p>
                   </a:txBody>
@@ -11345,7 +11337,7 @@
                           </a:solidFill>
                           <a:latin typeface="Calibri"/>
                         </a:rPr>
-                        <a:t>0,382 (0,357–0,413)</a:t>
+                        <a:t>0,366 (0,338–0,394)</a:t>
                       </a:r>
                     </a:p>
                   </a:txBody>
@@ -11368,7 +11360,7 @@
                           </a:solidFill>
                           <a:latin typeface="Calibri"/>
                         </a:rPr>
-                        <a:t>0,476</a:t>
+                        <a:t>0,450</a:t>
                       </a:r>
                     </a:p>
                   </a:txBody>
@@ -11391,7 +11383,7 @@
                           </a:solidFill>
                           <a:latin typeface="Calibri"/>
                         </a:rPr>
-                        <a:t>70,6%</a:t>
+                        <a:t>70,5%</a:t>
                       </a:r>
                     </a:p>
                   </a:txBody>
@@ -11462,7 +11454,7 @@
                           </a:solidFill>
                           <a:latin typeface="Calibri"/>
                         </a:rPr>
-                        <a:t>0,890 (0,879–0,901)</a:t>
+                        <a:t>0,891 (0,879–0,902)</a:t>
                       </a:r>
                     </a:p>
                   </a:txBody>
@@ -11485,7 +11477,7 @@
                           </a:solidFill>
                           <a:latin typeface="Calibri"/>
                         </a:rPr>
-                        <a:t>0,406 (0,380–0,437)</a:t>
+                        <a:t>0,390 (0,360–0,418)</a:t>
                       </a:r>
                     </a:p>
                   </a:txBody>
@@ -11508,7 +11500,7 @@
                           </a:solidFill>
                           <a:latin typeface="Calibri"/>
                         </a:rPr>
-                        <a:t>0,478</a:t>
+                        <a:t>0,454</a:t>
                       </a:r>
                     </a:p>
                   </a:txBody>
@@ -11531,7 +11523,7 @@
                           </a:solidFill>
                           <a:latin typeface="Calibri"/>
                         </a:rPr>
-                        <a:t>71,6%</a:t>
+                        <a:t>71,4%</a:t>
                       </a:r>
                     </a:p>
                   </a:txBody>
@@ -11602,7 +11594,7 @@
                           </a:solidFill>
                           <a:latin typeface="Calibri"/>
                         </a:rPr>
-                        <a:t>0,891 (0,880–0,902)</a:t>
+                        <a:t>0,890 (0,879–0,901)</a:t>
                       </a:r>
                     </a:p>
                   </a:txBody>
@@ -11625,7 +11617,7 @@
                           </a:solidFill>
                           <a:latin typeface="Calibri"/>
                         </a:rPr>
-                        <a:t>0,399 (0,372–0,429)</a:t>
+                        <a:t>0,396 (0,367–0,424)</a:t>
                       </a:r>
                     </a:p>
                   </a:txBody>
@@ -11648,7 +11640,7 @@
                           </a:solidFill>
                           <a:latin typeface="Calibri"/>
                         </a:rPr>
-                        <a:t>0,469</a:t>
+                        <a:t>0,457</a:t>
                       </a:r>
                     </a:p>
                   </a:txBody>
@@ -11671,7 +11663,7 @@
                           </a:solidFill>
                           <a:latin typeface="Calibri"/>
                         </a:rPr>
-                        <a:t>70,8%</a:t>
+                        <a:t>71,0%</a:t>
                       </a:r>
                     </a:p>
                   </a:txBody>
@@ -11754,7 +11746,7 @@
                 </a:solidFill>
                 <a:latin typeface="Calibri"/>
               </a:rPr>
-              <a:t>ΔAUROC 0,003, ΔAUPRC 0,042: ganho pequeno do boosting.</a:t>
+              <a:t>ΔAUROC 0,001, ΔAUPRC 0,052: ganho pequeno do boosting.</a:t>
             </a:r>
           </a:p>
         </p:txBody>
@@ -11906,7 +11898,7 @@
                 </a:solidFill>
                 <a:latin typeface="Calibri"/>
               </a:rPr>
-              <a:t>Priorizando 5% dos nascimentos, o modelo completo captura 87% dos óbitos; o pré-parto, 72%.</a:t>
+              <a:t>Priorizando 5% dos nascimentos, o modelo completo captura 88% dos óbitos; o pré-parto, 71%.</a:t>
             </a:r>
           </a:p>
         </p:txBody>

</xml_diff>